<commit_message>
Update Friday lecture with course site guidance
</commit_message>
<xml_diff>
--- a/slides/Math130CoordinateGeometry_2026-09-11.pptx
+++ b/slides/Math130CoordinateGeometry_2026-09-11.pptx
@@ -2,29 +2,29 @@
 <file path=ppt/presentation.xml><?xml version="1.0" encoding="utf-8"?>
 <p:presentation xmlns:p="http://schemas.openxmlformats.org/presentationml/2006/main">
   <p:sldMasterIdLst>
-    <p:sldMasterId xmlns:r="http://schemas.openxmlformats.org/officeDocument/2006/relationships" id="2147483648" r:id="R0a6627297c6046f3"/>
+    <p:sldMasterId xmlns:r="http://schemas.openxmlformats.org/officeDocument/2006/relationships" id="2147483648" r:id="Rf4604190b02e4904"/>
   </p:sldMasterIdLst>
   <p:notesMasterIdLst>
-    <p:notesMasterId xmlns:r="http://schemas.openxmlformats.org/officeDocument/2006/relationships" r:id="Rfd29091d37e84e73"/>
+    <p:notesMasterId xmlns:r="http://schemas.openxmlformats.org/officeDocument/2006/relationships" r:id="R89ffaf50f5fa46ee"/>
   </p:notesMasterIdLst>
   <p:sldIdLst>
-    <p:sldId xmlns:r="http://schemas.openxmlformats.org/officeDocument/2006/relationships" id="256" r:id="R64ec8cf65dd2455a"/>
-    <p:sldId xmlns:r="http://schemas.openxmlformats.org/officeDocument/2006/relationships" id="257" r:id="R72bb5e25c80c4fc4"/>
-    <p:sldId xmlns:r="http://schemas.openxmlformats.org/officeDocument/2006/relationships" id="258" r:id="Rbae1c972388d4e90"/>
-    <p:sldId xmlns:r="http://schemas.openxmlformats.org/officeDocument/2006/relationships" id="259" r:id="Rc9201e740dfd49c7"/>
-    <p:sldId xmlns:r="http://schemas.openxmlformats.org/officeDocument/2006/relationships" id="260" r:id="Re6b581b383c2400a"/>
-    <p:sldId xmlns:r="http://schemas.openxmlformats.org/officeDocument/2006/relationships" id="261" r:id="R6df071bdfe704bab"/>
-    <p:sldId xmlns:r="http://schemas.openxmlformats.org/officeDocument/2006/relationships" id="262" r:id="Ra0ca0f5cd91b4adc"/>
-    <p:sldId xmlns:r="http://schemas.openxmlformats.org/officeDocument/2006/relationships" id="263" r:id="R3d9150c9d88b4d89"/>
-    <p:sldId xmlns:r="http://schemas.openxmlformats.org/officeDocument/2006/relationships" id="264" r:id="Rbde1abc60c9f46cf"/>
-    <p:sldId xmlns:r="http://schemas.openxmlformats.org/officeDocument/2006/relationships" id="265" r:id="R7dc0c07af63f49d5"/>
-    <p:sldId xmlns:r="http://schemas.openxmlformats.org/officeDocument/2006/relationships" id="266" r:id="Re0f09cc8075a4786"/>
-    <p:sldId xmlns:r="http://schemas.openxmlformats.org/officeDocument/2006/relationships" id="267" r:id="R88d7ec22bb994922"/>
-    <p:sldId xmlns:r="http://schemas.openxmlformats.org/officeDocument/2006/relationships" id="268" r:id="R19722a09e296471f"/>
-    <p:sldId xmlns:r="http://schemas.openxmlformats.org/officeDocument/2006/relationships" id="269" r:id="Rb7a5a5862ca2478d"/>
-    <p:sldId xmlns:r="http://schemas.openxmlformats.org/officeDocument/2006/relationships" id="270" r:id="Ra41034953c12441c"/>
-    <p:sldId xmlns:r="http://schemas.openxmlformats.org/officeDocument/2006/relationships" id="271" r:id="Rb907c866543d4d02"/>
-    <p:sldId xmlns:r="http://schemas.openxmlformats.org/officeDocument/2006/relationships" id="272" r:id="R49c0ce52a42548b2"/>
+    <p:sldId xmlns:r="http://schemas.openxmlformats.org/officeDocument/2006/relationships" id="256" r:id="Rdd797ad9dc3a444f"/>
+    <p:sldId xmlns:r="http://schemas.openxmlformats.org/officeDocument/2006/relationships" id="257" r:id="R726795e409934142"/>
+    <p:sldId xmlns:r="http://schemas.openxmlformats.org/officeDocument/2006/relationships" id="258" r:id="Rc929941d884f4c7a"/>
+    <p:sldId xmlns:r="http://schemas.openxmlformats.org/officeDocument/2006/relationships" id="259" r:id="Rcf5dd25b413c4173"/>
+    <p:sldId xmlns:r="http://schemas.openxmlformats.org/officeDocument/2006/relationships" id="260" r:id="Rf1a511e045524d3b"/>
+    <p:sldId xmlns:r="http://schemas.openxmlformats.org/officeDocument/2006/relationships" id="261" r:id="Ra99bbcb761ec4a00"/>
+    <p:sldId xmlns:r="http://schemas.openxmlformats.org/officeDocument/2006/relationships" id="262" r:id="Rfd8baf7680214ffd"/>
+    <p:sldId xmlns:r="http://schemas.openxmlformats.org/officeDocument/2006/relationships" id="263" r:id="Re84618bfbe374c90"/>
+    <p:sldId xmlns:r="http://schemas.openxmlformats.org/officeDocument/2006/relationships" id="264" r:id="R625696f9040f4838"/>
+    <p:sldId xmlns:r="http://schemas.openxmlformats.org/officeDocument/2006/relationships" id="265" r:id="R6ce2f8b7133c4c21"/>
+    <p:sldId xmlns:r="http://schemas.openxmlformats.org/officeDocument/2006/relationships" id="266" r:id="R9c046934dbd2456e"/>
+    <p:sldId xmlns:r="http://schemas.openxmlformats.org/officeDocument/2006/relationships" id="267" r:id="R5e389b3f738e41e2"/>
+    <p:sldId xmlns:r="http://schemas.openxmlformats.org/officeDocument/2006/relationships" id="268" r:id="R13d4671f2bfe4b67"/>
+    <p:sldId xmlns:r="http://schemas.openxmlformats.org/officeDocument/2006/relationships" id="269" r:id="Rb23be26478174e6e"/>
+    <p:sldId xmlns:r="http://schemas.openxmlformats.org/officeDocument/2006/relationships" id="270" r:id="R4e5572ad8c1b441e"/>
+    <p:sldId xmlns:r="http://schemas.openxmlformats.org/officeDocument/2006/relationships" id="271" r:id="R3142ed9c5b1241bf"/>
+    <p:sldId xmlns:r="http://schemas.openxmlformats.org/officeDocument/2006/relationships" id="272" r:id="R16d935fd8ed84ab3"/>
   </p:sldIdLst>
   <p:sldSz cx="12192000" cy="6858000"/>
   <p:notesSz cx="6858000" cy="9144000"/>
@@ -1018,7 +1018,7 @@
           <a:lstStyle xmlns:a="http://schemas.openxmlformats.org/drawingml/2006/main"/>
           <a:p xmlns:a="http://schemas.openxmlformats.org/drawingml/2006/main">
             <a:r>
-              <a:t>4:02–4:05. Collect the exit response or check it at the door. Midpoint = (−1, 2). Slope = (−2 − 6)/(2 − (−4)) = −8/6 = −4/3. Remind students to complete Sections 2.1, 2.2, and 2.4 before Quiz 3 and to use Canvas for the exact deadline.</a:t>
+              <a:t>4:02–4:05. Collect the exit response or check it at the door. Midpoint = (−1, 2), slope = −4/3. Then return students to the MATH 130 dashboard: continue Unit 1C, finish ALEKS Sections 2.1, 2.2, and 2.4, and use the Unit 1C practice and checkpoint before Quiz 3. Canvas remains the master source for the deadline.</a:t>
             </a:r>
           </a:p>
         </p:txBody>
@@ -1088,7 +1088,7 @@
           <a:lstStyle xmlns:a="http://schemas.openxmlformats.org/drawingml/2006/main"/>
           <a:p xmlns:a="http://schemas.openxmlformats.org/drawingml/2006/main">
             <a:r>
-              <a:t>3:16–3:17. Preview the timing. Protect the practice blocks and the final three-minute exit ticket.</a:t>
+              <a:t>3:16–3:17. Preview the timing. The first three minutes introduce the updated MATH 130 course site and the Unit 1C route. Protect the practice blocks and the final three minutes for the exit ticket and next steps.</a:t>
             </a:r>
           </a:p>
         </p:txBody>
@@ -1158,7 +1158,7 @@
           <a:lstStyle xmlns:a="http://schemas.openxmlformats.org/drawingml/2006/main"/>
           <a:p xmlns:a="http://schemas.openxmlformats.org/drawingml/2006/main">
             <a:r>
-              <a:t>3:17–3:18. The chart uses aggregate class readiness from itemsReport (2).xlsx, generated September 9, 2026. Ready-to-learn shares: exact distance 85%, decimal distance 73%, midpoint 66%, advanced intercepts 56%, and circle identification 49%. Current-module average progress is 36.2%. Do not identify individual students.</a:t>
+              <a:t>3:17–3:18. Open andrewhvolk.github.io/courses/math130.html. The updated dashboard puts Unit 1C first. Point out Plan, Learn, Practice, and Progress. Students should complete ALEKS Sections 2.1, 2.2, and 2.4 through Canvas, then use the Unit 1C practice and checkpoint before Quiz 3 on Tuesday, September 16. The chart still reflects the September 9 ALEKS report. Canvas remains the master source for dates and coverage changes.</a:t>
             </a:r>
           </a:p>
         </p:txBody>
@@ -1646,7 +1646,7 @@
   </p:cSld>
   <p:clrMap bg1="lt1" tx1="dk1" bg2="lt2" tx2="dk2" accent1="accent1" accent2="accent2" accent3="accent3" accent4="accent4" accent5="accent5" accent6="accent6" hlink="hlink" folHlink="folHlink"/>
   <p:sldLayoutIdLst>
-    <p:sldLayoutId xmlns:r="http://schemas.openxmlformats.org/officeDocument/2006/relationships" id="2147483649" r:id="R54d43731459f401a"/>
+    <p:sldLayoutId xmlns:r="http://schemas.openxmlformats.org/officeDocument/2006/relationships" id="2147483649" r:id="R348ce9d10b944101"/>
   </p:sldLayoutIdLst>
   <p:txStyles>
     <p:titleStyle>
@@ -2293,7 +2293,7 @@
           <a:lstStyle xmlns:a="http://schemas.openxmlformats.org/drawingml/2006/main"/>
           <a:p xmlns:a="http://schemas.openxmlformats.org/drawingml/2006/main">
             <a:pPr>
-              <a:defRPr>
+              <a:defRPr sz="975">
                 <a:solidFill>
                   <a:srgbClr val="666666"/>
                 </a:solidFill>
@@ -2311,7 +2311,7 @@
         <c:scaling>
           <c:orientation val="minMax"/>
         </c:scaling>
-        <c:delete val="1"/>
+        <c:delete val="0"/>
         <c:axPos val="b"/>
         <c:numFmt formatCode="General"/>
         <c:majorTickMark val="none"/>
@@ -2329,7 +2329,7 @@
           <a:lstStyle xmlns:a="http://schemas.openxmlformats.org/drawingml/2006/main"/>
           <a:p xmlns:a="http://schemas.openxmlformats.org/drawingml/2006/main">
             <a:pPr>
-              <a:defRPr>
+              <a:defRPr sz="975">
                 <a:solidFill>
                   <a:srgbClr val="666666"/>
                 </a:solidFill>
@@ -2343,9 +2343,25 @@
         <c:crossAx val="48650112"/>
         <c:crossBetween val="between"/>
       </c:valAx>
+      <c:spPr>
+        <a:solidFill xmlns:a="http://schemas.openxmlformats.org/drawingml/2006/main">
+          <a:srgbClr val="FFFFFF"/>
+        </a:solidFill>
+        <a:ln xmlns:a="http://schemas.openxmlformats.org/drawingml/2006/main" w="0">
+          <a:noFill/>
+        </a:ln>
+      </c:spPr>
     </c:plotArea>
     <c:plotVisOnly val="1"/>
   </c:chart>
+  <c:spPr>
+    <a:solidFill xmlns:a="http://schemas.openxmlformats.org/drawingml/2006/main">
+      <a:srgbClr val="FFFFFF"/>
+    </a:solidFill>
+    <a:ln xmlns:a="http://schemas.openxmlformats.org/drawingml/2006/main" w="0">
+      <a:noFill/>
+    </a:ln>
+  </c:spPr>
   <c:externalData r:id="rIdChartSnapshot1">
     <c:autoUpdate val="0"/>
   </c:externalData>
@@ -2435,6 +2451,7 @@
           <a:lstStyle xmlns:a="http://schemas.openxmlformats.org/drawingml/2006/main"/>
           <a:p xmlns:a="http://schemas.openxmlformats.org/drawingml/2006/main">
             <a:pPr algn="l">
+              <a:buNone/>
               <a:defRPr sz="1050" b="1" i="0">
                 <a:solidFill>
                   <a:srgbClr val="168A6B"/>
@@ -2492,6 +2509,7 @@
           <a:lstStyle xmlns:a="http://schemas.openxmlformats.org/drawingml/2006/main"/>
           <a:p xmlns:a="http://schemas.openxmlformats.org/drawingml/2006/main">
             <a:pPr algn="l">
+              <a:buNone/>
               <a:defRPr sz="3600" b="1" i="0">
                 <a:solidFill>
                   <a:srgbClr val="FFFFFF"/>
@@ -2549,6 +2567,7 @@
           <a:lstStyle xmlns:a="http://schemas.openxmlformats.org/drawingml/2006/main"/>
           <a:p xmlns:a="http://schemas.openxmlformats.org/drawingml/2006/main">
             <a:pPr algn="l">
+              <a:buNone/>
               <a:defRPr sz="1800" b="0" i="0">
                 <a:solidFill>
                   <a:srgbClr val="D6E4EC"/>
@@ -2636,6 +2655,7 @@
           <a:lstStyle xmlns:a="http://schemas.openxmlformats.org/drawingml/2006/main"/>
           <a:p xmlns:a="http://schemas.openxmlformats.org/drawingml/2006/main">
             <a:pPr algn="l">
+              <a:buNone/>
               <a:defRPr sz="1650" b="1" i="0">
                 <a:solidFill>
                   <a:srgbClr val="FFFFFF"/>
@@ -2659,6 +2679,7 @@
           </a:p>
           <a:p xmlns:a="http://schemas.openxmlformats.org/drawingml/2006/main">
             <a:pPr algn="l">
+              <a:buNone/>
               <a:defRPr sz="1650" b="1" i="0">
                 <a:solidFill>
                   <a:srgbClr val="FFFFFF"/>
@@ -2716,6 +2737,7 @@
           <a:lstStyle xmlns:a="http://schemas.openxmlformats.org/drawingml/2006/main"/>
           <a:p xmlns:a="http://schemas.openxmlformats.org/drawingml/2006/main">
             <a:pPr algn="ctr">
+              <a:buNone/>
               <a:defRPr sz="4500" b="1" i="0">
                 <a:solidFill>
                   <a:srgbClr val="168A6B"/>
@@ -2773,6 +2795,7 @@
           <a:lstStyle xmlns:a="http://schemas.openxmlformats.org/drawingml/2006/main"/>
           <a:p xmlns:a="http://schemas.openxmlformats.org/drawingml/2006/main">
             <a:pPr algn="ctr">
+              <a:buNone/>
               <a:defRPr sz="1800" b="1" i="0">
                 <a:solidFill>
                   <a:srgbClr val="F4B52A"/>
@@ -2830,6 +2853,7 @@
           <a:lstStyle xmlns:a="http://schemas.openxmlformats.org/drawingml/2006/main"/>
           <a:p xmlns:a="http://schemas.openxmlformats.org/drawingml/2006/main">
             <a:pPr algn="ctr">
+              <a:buNone/>
               <a:defRPr sz="975" b="1" i="0">
                 <a:solidFill>
                   <a:srgbClr val="D6E4EC"/>
@@ -2887,6 +2911,7 @@
           <a:lstStyle xmlns:a="http://schemas.openxmlformats.org/drawingml/2006/main"/>
           <a:p xmlns:a="http://schemas.openxmlformats.org/drawingml/2006/main">
             <a:pPr algn="l">
+              <a:buNone/>
               <a:defRPr sz="1275" b="1" i="0">
                 <a:solidFill>
                   <a:srgbClr val="F4B52A"/>
@@ -2905,7 +2930,7 @@
                 <a:ea typeface="Arial"/>
                 <a:cs typeface="Arial"/>
               </a:rPr>
-              <a:t>Complete the current module before Quiz 3</a:t>
+              <a:t>Course site: Unit 1C lesson, practice, checkpoint</a:t>
             </a:r>
           </a:p>
         </p:txBody>
@@ -2944,6 +2969,7 @@
           <a:lstStyle xmlns:a="http://schemas.openxmlformats.org/drawingml/2006/main"/>
           <a:p xmlns:a="http://schemas.openxmlformats.org/drawingml/2006/main">
             <a:pPr algn="r">
+              <a:buNone/>
               <a:defRPr sz="675" b="0" i="0">
                 <a:solidFill>
                   <a:srgbClr val="AFC2CF"/>
@@ -3060,6 +3086,7 @@
           <a:lstStyle xmlns:a="http://schemas.openxmlformats.org/drawingml/2006/main"/>
           <a:p xmlns:a="http://schemas.openxmlformats.org/drawingml/2006/main">
             <a:pPr algn="l">
+              <a:buNone/>
               <a:defRPr sz="2250" b="1" i="0">
                 <a:solidFill>
                   <a:srgbClr val="193B55"/>
@@ -3117,6 +3144,7 @@
           <a:lstStyle xmlns:a="http://schemas.openxmlformats.org/drawingml/2006/main"/>
           <a:p xmlns:a="http://schemas.openxmlformats.org/drawingml/2006/main">
             <a:pPr algn="l">
+              <a:buNone/>
               <a:defRPr sz="1125" b="0" i="0">
                 <a:solidFill>
                   <a:srgbClr val="60798D"/>
@@ -3174,6 +3202,7 @@
           <a:lstStyle xmlns:a="http://schemas.openxmlformats.org/drawingml/2006/main"/>
           <a:p xmlns:a="http://schemas.openxmlformats.org/drawingml/2006/main">
             <a:pPr algn="r">
+              <a:buNone/>
               <a:defRPr sz="900" b="1" i="0">
                 <a:solidFill>
                   <a:srgbClr val="168A6B"/>
@@ -3261,6 +3290,7 @@
           <a:lstStyle xmlns:a="http://schemas.openxmlformats.org/drawingml/2006/main"/>
           <a:p xmlns:a="http://schemas.openxmlformats.org/drawingml/2006/main">
             <a:pPr algn="l">
+              <a:buNone/>
               <a:defRPr sz="675" b="1" i="0">
                 <a:solidFill>
                   <a:srgbClr val="60798D"/>
@@ -3318,6 +3348,7 @@
           <a:lstStyle xmlns:a="http://schemas.openxmlformats.org/drawingml/2006/main"/>
           <a:p xmlns:a="http://schemas.openxmlformats.org/drawingml/2006/main">
             <a:pPr algn="r">
+              <a:buNone/>
               <a:defRPr sz="675" b="0" i="0">
                 <a:solidFill>
                   <a:srgbClr val="60798D"/>
@@ -3405,6 +3436,7 @@
           <a:lstStyle xmlns:a="http://schemas.openxmlformats.org/drawingml/2006/main"/>
           <a:p xmlns:a="http://schemas.openxmlformats.org/drawingml/2006/main">
             <a:pPr algn="ctr">
+              <a:buNone/>
               <a:defRPr sz="2250" b="1" i="0">
                 <a:solidFill>
                   <a:srgbClr val="193B55"/>
@@ -3492,6 +3524,7 @@
           <a:lstStyle xmlns:a="http://schemas.openxmlformats.org/drawingml/2006/main"/>
           <a:p xmlns:a="http://schemas.openxmlformats.org/drawingml/2006/main">
             <a:pPr algn="l">
+              <a:buNone/>
               <a:defRPr sz="1500" b="1" i="0">
                 <a:solidFill>
                   <a:srgbClr val="1777B4"/>
@@ -3549,6 +3582,7 @@
           <a:lstStyle xmlns:a="http://schemas.openxmlformats.org/drawingml/2006/main"/>
           <a:p xmlns:a="http://schemas.openxmlformats.org/drawingml/2006/main">
             <a:pPr algn="ctr">
+              <a:buNone/>
               <a:defRPr sz="2175" b="1" i="0">
                 <a:solidFill>
                   <a:srgbClr val="193B55"/>
@@ -3572,6 +3606,7 @@
           </a:p>
           <a:p xmlns:a="http://schemas.openxmlformats.org/drawingml/2006/main">
             <a:pPr algn="ctr">
+              <a:buNone/>
               <a:defRPr sz="2175" b="1" i="0">
                 <a:solidFill>
                   <a:srgbClr val="193B55"/>
@@ -3595,6 +3630,7 @@
           </a:p>
           <a:p xmlns:a="http://schemas.openxmlformats.org/drawingml/2006/main">
             <a:pPr algn="ctr">
+              <a:buNone/>
               <a:defRPr sz="2175" b="1" i="0">
                 <a:solidFill>
                   <a:srgbClr val="193B55"/>
@@ -3682,6 +3718,7 @@
           <a:lstStyle xmlns:a="http://schemas.openxmlformats.org/drawingml/2006/main"/>
           <a:p xmlns:a="http://schemas.openxmlformats.org/drawingml/2006/main">
             <a:pPr algn="l">
+              <a:buNone/>
               <a:defRPr sz="1500" b="1" i="0">
                 <a:solidFill>
                   <a:srgbClr val="168A6B"/>
@@ -3739,6 +3776,7 @@
           <a:lstStyle xmlns:a="http://schemas.openxmlformats.org/drawingml/2006/main"/>
           <a:p xmlns:a="http://schemas.openxmlformats.org/drawingml/2006/main">
             <a:pPr algn="ctr">
+              <a:buNone/>
               <a:defRPr sz="2025" b="1" i="0">
                 <a:solidFill>
                   <a:srgbClr val="193B55"/>
@@ -3762,6 +3800,7 @@
           </a:p>
           <a:p xmlns:a="http://schemas.openxmlformats.org/drawingml/2006/main">
             <a:pPr algn="ctr">
+              <a:buNone/>
               <a:defRPr sz="2025" b="1" i="0">
                 <a:solidFill>
                   <a:srgbClr val="193B55"/>
@@ -3785,6 +3824,7 @@
           </a:p>
           <a:p xmlns:a="http://schemas.openxmlformats.org/drawingml/2006/main">
             <a:pPr algn="ctr">
+              <a:buNone/>
               <a:defRPr sz="2025" b="1" i="0">
                 <a:solidFill>
                   <a:srgbClr val="193B55"/>
@@ -3842,6 +3882,7 @@
           <a:lstStyle xmlns:a="http://schemas.openxmlformats.org/drawingml/2006/main"/>
           <a:p xmlns:a="http://schemas.openxmlformats.org/drawingml/2006/main">
             <a:pPr algn="ctr">
+              <a:buNone/>
               <a:defRPr sz="1425" b="1" i="0">
                 <a:solidFill>
                   <a:srgbClr val="168A6B"/>
@@ -3958,6 +3999,7 @@
           <a:lstStyle xmlns:a="http://schemas.openxmlformats.org/drawingml/2006/main"/>
           <a:p xmlns:a="http://schemas.openxmlformats.org/drawingml/2006/main">
             <a:pPr algn="l">
+              <a:buNone/>
               <a:defRPr sz="2250" b="1" i="0">
                 <a:solidFill>
                   <a:srgbClr val="193B55"/>
@@ -4015,6 +4057,7 @@
           <a:lstStyle xmlns:a="http://schemas.openxmlformats.org/drawingml/2006/main"/>
           <a:p xmlns:a="http://schemas.openxmlformats.org/drawingml/2006/main">
             <a:pPr algn="l">
+              <a:buNone/>
               <a:defRPr sz="1125" b="0" i="0">
                 <a:solidFill>
                   <a:srgbClr val="60798D"/>
@@ -4072,6 +4115,7 @@
           <a:lstStyle xmlns:a="http://schemas.openxmlformats.org/drawingml/2006/main"/>
           <a:p xmlns:a="http://schemas.openxmlformats.org/drawingml/2006/main">
             <a:pPr algn="r">
+              <a:buNone/>
               <a:defRPr sz="900" b="1" i="0">
                 <a:solidFill>
                   <a:srgbClr val="1777B4"/>
@@ -4159,6 +4203,7 @@
           <a:lstStyle xmlns:a="http://schemas.openxmlformats.org/drawingml/2006/main"/>
           <a:p xmlns:a="http://schemas.openxmlformats.org/drawingml/2006/main">
             <a:pPr algn="l">
+              <a:buNone/>
               <a:defRPr sz="675" b="1" i="0">
                 <a:solidFill>
                   <a:srgbClr val="60798D"/>
@@ -4216,6 +4261,7 @@
           <a:lstStyle xmlns:a="http://schemas.openxmlformats.org/drawingml/2006/main"/>
           <a:p xmlns:a="http://schemas.openxmlformats.org/drawingml/2006/main">
             <a:pPr algn="r">
+              <a:buNone/>
               <a:defRPr sz="675" b="0" i="0">
                 <a:solidFill>
                   <a:srgbClr val="60798D"/>
@@ -4303,6 +4349,7 @@
           <a:lstStyle xmlns:a="http://schemas.openxmlformats.org/drawingml/2006/main"/>
           <a:p xmlns:a="http://schemas.openxmlformats.org/drawingml/2006/main">
             <a:pPr algn="ctr">
+              <a:buNone/>
               <a:defRPr sz="2700" b="1" i="0">
                 <a:solidFill>
                   <a:srgbClr val="193B55"/>
@@ -4360,6 +4407,7 @@
           <a:lstStyle xmlns:a="http://schemas.openxmlformats.org/drawingml/2006/main"/>
           <a:p xmlns:a="http://schemas.openxmlformats.org/drawingml/2006/main">
             <a:pPr algn="ctr">
+              <a:buNone/>
               <a:defRPr sz="1500" b="1" i="0">
                 <a:solidFill>
                   <a:srgbClr val="E45D50"/>
@@ -4447,6 +4495,7 @@
           <a:lstStyle xmlns:a="http://schemas.openxmlformats.org/drawingml/2006/main"/>
           <a:p xmlns:a="http://schemas.openxmlformats.org/drawingml/2006/main">
             <a:pPr algn="ctr">
+              <a:buNone/>
               <a:defRPr sz="2550" b="1" i="0">
                 <a:solidFill>
                   <a:srgbClr val="193B55"/>
@@ -4470,6 +4519,7 @@
           </a:p>
           <a:p xmlns:a="http://schemas.openxmlformats.org/drawingml/2006/main">
             <a:pPr algn="ctr">
+              <a:buNone/>
               <a:defRPr sz="2550" b="1" i="0">
                 <a:solidFill>
                   <a:srgbClr val="193B55"/>
@@ -4527,6 +4577,7 @@
           <a:lstStyle xmlns:a="http://schemas.openxmlformats.org/drawingml/2006/main"/>
           <a:p xmlns:a="http://schemas.openxmlformats.org/drawingml/2006/main">
             <a:pPr algn="ctr">
+              <a:buNone/>
               <a:defRPr sz="1425" b="1" i="0">
                 <a:solidFill>
                   <a:srgbClr val="1777B4"/>
@@ -4643,6 +4694,7 @@
           <a:lstStyle xmlns:a="http://schemas.openxmlformats.org/drawingml/2006/main"/>
           <a:p xmlns:a="http://schemas.openxmlformats.org/drawingml/2006/main">
             <a:pPr algn="l">
+              <a:buNone/>
               <a:defRPr sz="2250" b="1" i="0">
                 <a:solidFill>
                   <a:srgbClr val="193B55"/>
@@ -4700,6 +4752,7 @@
           <a:lstStyle xmlns:a="http://schemas.openxmlformats.org/drawingml/2006/main"/>
           <a:p xmlns:a="http://schemas.openxmlformats.org/drawingml/2006/main">
             <a:pPr algn="l">
+              <a:buNone/>
               <a:defRPr sz="1125" b="0" i="0">
                 <a:solidFill>
                   <a:srgbClr val="60798D"/>
@@ -4757,6 +4810,7 @@
           <a:lstStyle xmlns:a="http://schemas.openxmlformats.org/drawingml/2006/main"/>
           <a:p xmlns:a="http://schemas.openxmlformats.org/drawingml/2006/main">
             <a:pPr algn="r">
+              <a:buNone/>
               <a:defRPr sz="900" b="1" i="0">
                 <a:solidFill>
                   <a:srgbClr val="1777B4"/>
@@ -4844,6 +4898,7 @@
           <a:lstStyle xmlns:a="http://schemas.openxmlformats.org/drawingml/2006/main"/>
           <a:p xmlns:a="http://schemas.openxmlformats.org/drawingml/2006/main">
             <a:pPr algn="l">
+              <a:buNone/>
               <a:defRPr sz="675" b="1" i="0">
                 <a:solidFill>
                   <a:srgbClr val="60798D"/>
@@ -4901,6 +4956,7 @@
           <a:lstStyle xmlns:a="http://schemas.openxmlformats.org/drawingml/2006/main"/>
           <a:p xmlns:a="http://schemas.openxmlformats.org/drawingml/2006/main">
             <a:pPr algn="r">
+              <a:buNone/>
               <a:defRPr sz="675" b="0" i="0">
                 <a:solidFill>
                   <a:srgbClr val="60798D"/>
@@ -4988,6 +5044,7 @@
           <a:lstStyle xmlns:a="http://schemas.openxmlformats.org/drawingml/2006/main"/>
           <a:p xmlns:a="http://schemas.openxmlformats.org/drawingml/2006/main">
             <a:pPr algn="l">
+              <a:buNone/>
               <a:defRPr sz="1725" b="1" i="0">
                 <a:solidFill>
                   <a:srgbClr val="1777B4"/>
@@ -5045,6 +5102,7 @@
           <a:lstStyle xmlns:a="http://schemas.openxmlformats.org/drawingml/2006/main"/>
           <a:p xmlns:a="http://schemas.openxmlformats.org/drawingml/2006/main">
             <a:pPr algn="ctr">
+              <a:buNone/>
               <a:defRPr sz="2100" b="1" i="0">
                 <a:solidFill>
                   <a:srgbClr val="193B55"/>
@@ -5102,6 +5160,7 @@
           <a:lstStyle xmlns:a="http://schemas.openxmlformats.org/drawingml/2006/main"/>
           <a:p xmlns:a="http://schemas.openxmlformats.org/drawingml/2006/main">
             <a:pPr algn="ctr">
+              <a:buNone/>
               <a:defRPr sz="2175" b="1" i="0">
                 <a:solidFill>
                   <a:srgbClr val="193B55"/>
@@ -5125,6 +5184,7 @@
           </a:p>
           <a:p xmlns:a="http://schemas.openxmlformats.org/drawingml/2006/main">
             <a:pPr algn="ctr">
+              <a:buNone/>
               <a:defRPr sz="2175" b="1" i="0">
                 <a:solidFill>
                   <a:srgbClr val="193B55"/>
@@ -5182,6 +5242,7 @@
           <a:lstStyle xmlns:a="http://schemas.openxmlformats.org/drawingml/2006/main"/>
           <a:p xmlns:a="http://schemas.openxmlformats.org/drawingml/2006/main">
             <a:pPr algn="ctr">
+              <a:buNone/>
               <a:defRPr sz="1425" b="1" i="0">
                 <a:solidFill>
                   <a:srgbClr val="1777B4"/>
@@ -5269,6 +5330,7 @@
           <a:lstStyle xmlns:a="http://schemas.openxmlformats.org/drawingml/2006/main"/>
           <a:p xmlns:a="http://schemas.openxmlformats.org/drawingml/2006/main">
             <a:pPr algn="l">
+              <a:buNone/>
               <a:defRPr sz="1725" b="1" i="0">
                 <a:solidFill>
                   <a:srgbClr val="E45D50"/>
@@ -5326,6 +5388,7 @@
           <a:lstStyle xmlns:a="http://schemas.openxmlformats.org/drawingml/2006/main"/>
           <a:p xmlns:a="http://schemas.openxmlformats.org/drawingml/2006/main">
             <a:pPr algn="ctr">
+              <a:buNone/>
               <a:defRPr sz="2100" b="1" i="0">
                 <a:solidFill>
                   <a:srgbClr val="193B55"/>
@@ -5383,6 +5446,7 @@
           <a:lstStyle xmlns:a="http://schemas.openxmlformats.org/drawingml/2006/main"/>
           <a:p xmlns:a="http://schemas.openxmlformats.org/drawingml/2006/main">
             <a:pPr algn="ctr">
+              <a:buNone/>
               <a:defRPr sz="2100" b="1" i="0">
                 <a:solidFill>
                   <a:srgbClr val="193B55"/>
@@ -5406,6 +5470,7 @@
           </a:p>
           <a:p xmlns:a="http://schemas.openxmlformats.org/drawingml/2006/main">
             <a:pPr algn="ctr">
+              <a:buNone/>
               <a:defRPr sz="2100" b="1" i="0">
                 <a:solidFill>
                   <a:srgbClr val="193B55"/>
@@ -5463,6 +5528,7 @@
           <a:lstStyle xmlns:a="http://schemas.openxmlformats.org/drawingml/2006/main"/>
           <a:p xmlns:a="http://schemas.openxmlformats.org/drawingml/2006/main">
             <a:pPr algn="ctr">
+              <a:buNone/>
               <a:defRPr sz="1425" b="1" i="0">
                 <a:solidFill>
                   <a:srgbClr val="E45D50"/>
@@ -5550,6 +5616,7 @@
           <a:lstStyle xmlns:a="http://schemas.openxmlformats.org/drawingml/2006/main"/>
           <a:p xmlns:a="http://schemas.openxmlformats.org/drawingml/2006/main">
             <a:pPr algn="ctr">
+              <a:buNone/>
               <a:defRPr sz="1650" b="1" i="0">
                 <a:solidFill>
                   <a:srgbClr val="193B55"/>
@@ -5666,6 +5733,7 @@
           <a:lstStyle xmlns:a="http://schemas.openxmlformats.org/drawingml/2006/main"/>
           <a:p xmlns:a="http://schemas.openxmlformats.org/drawingml/2006/main">
             <a:pPr algn="l">
+              <a:buNone/>
               <a:defRPr sz="2250" b="1" i="0">
                 <a:solidFill>
                   <a:srgbClr val="193B55"/>
@@ -5723,6 +5791,7 @@
           <a:lstStyle xmlns:a="http://schemas.openxmlformats.org/drawingml/2006/main"/>
           <a:p xmlns:a="http://schemas.openxmlformats.org/drawingml/2006/main">
             <a:pPr algn="l">
+              <a:buNone/>
               <a:defRPr sz="1125" b="0" i="0">
                 <a:solidFill>
                   <a:srgbClr val="60798D"/>
@@ -5780,6 +5849,7 @@
           <a:lstStyle xmlns:a="http://schemas.openxmlformats.org/drawingml/2006/main"/>
           <a:p xmlns:a="http://schemas.openxmlformats.org/drawingml/2006/main">
             <a:pPr algn="r">
+              <a:buNone/>
               <a:defRPr sz="900" b="1" i="0">
                 <a:solidFill>
                   <a:srgbClr val="1777B4"/>
@@ -5867,6 +5937,7 @@
           <a:lstStyle xmlns:a="http://schemas.openxmlformats.org/drawingml/2006/main"/>
           <a:p xmlns:a="http://schemas.openxmlformats.org/drawingml/2006/main">
             <a:pPr algn="l">
+              <a:buNone/>
               <a:defRPr sz="675" b="1" i="0">
                 <a:solidFill>
                   <a:srgbClr val="60798D"/>
@@ -5924,6 +5995,7 @@
           <a:lstStyle xmlns:a="http://schemas.openxmlformats.org/drawingml/2006/main"/>
           <a:p xmlns:a="http://schemas.openxmlformats.org/drawingml/2006/main">
             <a:pPr algn="r">
+              <a:buNone/>
               <a:defRPr sz="675" b="0" i="0">
                 <a:solidFill>
                   <a:srgbClr val="60798D"/>
@@ -6011,6 +6083,7 @@
           <a:lstStyle xmlns:a="http://schemas.openxmlformats.org/drawingml/2006/main"/>
           <a:p xmlns:a="http://schemas.openxmlformats.org/drawingml/2006/main">
             <a:pPr algn="ctr">
+              <a:buNone/>
               <a:defRPr sz="1500" b="1" i="0">
                 <a:solidFill>
                   <a:srgbClr val="FFFFFF"/>
@@ -6068,6 +6141,7 @@
           <a:lstStyle xmlns:a="http://schemas.openxmlformats.org/drawingml/2006/main"/>
           <a:p xmlns:a="http://schemas.openxmlformats.org/drawingml/2006/main">
             <a:pPr algn="l">
+              <a:buNone/>
               <a:defRPr sz="1725" b="1" i="0">
                 <a:solidFill>
                   <a:srgbClr val="193B55"/>
@@ -6155,6 +6229,7 @@
           <a:lstStyle xmlns:a="http://schemas.openxmlformats.org/drawingml/2006/main"/>
           <a:p xmlns:a="http://schemas.openxmlformats.org/drawingml/2006/main">
             <a:pPr algn="ctr">
+              <a:buNone/>
               <a:defRPr sz="1500" b="1" i="0">
                 <a:solidFill>
                   <a:srgbClr val="FFFFFF"/>
@@ -6212,6 +6287,7 @@
           <a:lstStyle xmlns:a="http://schemas.openxmlformats.org/drawingml/2006/main"/>
           <a:p xmlns:a="http://schemas.openxmlformats.org/drawingml/2006/main">
             <a:pPr algn="l">
+              <a:buNone/>
               <a:defRPr sz="1725" b="1" i="0">
                 <a:solidFill>
                   <a:srgbClr val="193B55"/>
@@ -6299,6 +6375,7 @@
           <a:lstStyle xmlns:a="http://schemas.openxmlformats.org/drawingml/2006/main"/>
           <a:p xmlns:a="http://schemas.openxmlformats.org/drawingml/2006/main">
             <a:pPr algn="ctr">
+              <a:buNone/>
               <a:defRPr sz="1500" b="1" i="0">
                 <a:solidFill>
                   <a:srgbClr val="FFFFFF"/>
@@ -6356,6 +6433,7 @@
           <a:lstStyle xmlns:a="http://schemas.openxmlformats.org/drawingml/2006/main"/>
           <a:p xmlns:a="http://schemas.openxmlformats.org/drawingml/2006/main">
             <a:pPr algn="l">
+              <a:buNone/>
               <a:defRPr sz="1725" b="1" i="0">
                 <a:solidFill>
                   <a:srgbClr val="193B55"/>
@@ -6443,6 +6521,7 @@
           <a:lstStyle xmlns:a="http://schemas.openxmlformats.org/drawingml/2006/main"/>
           <a:p xmlns:a="http://schemas.openxmlformats.org/drawingml/2006/main">
             <a:pPr algn="l">
+              <a:buNone/>
               <a:defRPr sz="1350" b="1" i="0">
                 <a:solidFill>
                   <a:srgbClr val="1777B4"/>
@@ -6500,6 +6579,7 @@
           <a:lstStyle xmlns:a="http://schemas.openxmlformats.org/drawingml/2006/main"/>
           <a:p xmlns:a="http://schemas.openxmlformats.org/drawingml/2006/main">
             <a:pPr algn="ctr">
+              <a:buNone/>
               <a:defRPr sz="2025" b="1" i="0">
                 <a:solidFill>
                   <a:srgbClr val="193B55"/>
@@ -6557,6 +6637,7 @@
           <a:lstStyle xmlns:a="http://schemas.openxmlformats.org/drawingml/2006/main"/>
           <a:p xmlns:a="http://schemas.openxmlformats.org/drawingml/2006/main">
             <a:pPr algn="ctr">
+              <a:buNone/>
               <a:defRPr sz="1275" b="0" i="0">
                 <a:solidFill>
                   <a:srgbClr val="60798D"/>
@@ -6673,6 +6754,7 @@
           <a:lstStyle xmlns:a="http://schemas.openxmlformats.org/drawingml/2006/main"/>
           <a:p xmlns:a="http://schemas.openxmlformats.org/drawingml/2006/main">
             <a:pPr algn="l">
+              <a:buNone/>
               <a:defRPr sz="2250" b="1" i="0">
                 <a:solidFill>
                   <a:srgbClr val="193B55"/>
@@ -6730,6 +6812,7 @@
           <a:lstStyle xmlns:a="http://schemas.openxmlformats.org/drawingml/2006/main"/>
           <a:p xmlns:a="http://schemas.openxmlformats.org/drawingml/2006/main">
             <a:pPr algn="l">
+              <a:buNone/>
               <a:defRPr sz="1125" b="0" i="0">
                 <a:solidFill>
                   <a:srgbClr val="60798D"/>
@@ -6787,6 +6870,7 @@
           <a:lstStyle xmlns:a="http://schemas.openxmlformats.org/drawingml/2006/main"/>
           <a:p xmlns:a="http://schemas.openxmlformats.org/drawingml/2006/main">
             <a:pPr algn="r">
+              <a:buNone/>
               <a:defRPr sz="900" b="1" i="0">
                 <a:solidFill>
                   <a:srgbClr val="F4B52A"/>
@@ -6874,6 +6958,7 @@
           <a:lstStyle xmlns:a="http://schemas.openxmlformats.org/drawingml/2006/main"/>
           <a:p xmlns:a="http://schemas.openxmlformats.org/drawingml/2006/main">
             <a:pPr algn="l">
+              <a:buNone/>
               <a:defRPr sz="675" b="1" i="0">
                 <a:solidFill>
                   <a:srgbClr val="60798D"/>
@@ -6931,6 +7016,7 @@
           <a:lstStyle xmlns:a="http://schemas.openxmlformats.org/drawingml/2006/main"/>
           <a:p xmlns:a="http://schemas.openxmlformats.org/drawingml/2006/main">
             <a:pPr algn="r">
+              <a:buNone/>
               <a:defRPr sz="675" b="0" i="0">
                 <a:solidFill>
                   <a:srgbClr val="60798D"/>
@@ -7018,6 +7104,7 @@
           <a:lstStyle xmlns:a="http://schemas.openxmlformats.org/drawingml/2006/main"/>
           <a:p xmlns:a="http://schemas.openxmlformats.org/drawingml/2006/main">
             <a:pPr algn="ctr">
+              <a:buNone/>
               <a:defRPr sz="1500" b="1" i="0">
                 <a:solidFill>
                   <a:srgbClr val="FFFFFF"/>
@@ -7075,6 +7162,7 @@
           <a:lstStyle xmlns:a="http://schemas.openxmlformats.org/drawingml/2006/main"/>
           <a:p xmlns:a="http://schemas.openxmlformats.org/drawingml/2006/main">
             <a:pPr algn="l">
+              <a:buNone/>
               <a:defRPr sz="1875" b="1" i="0">
                 <a:solidFill>
                   <a:srgbClr val="193B55"/>
@@ -7162,6 +7250,7 @@
           <a:lstStyle xmlns:a="http://schemas.openxmlformats.org/drawingml/2006/main"/>
           <a:p xmlns:a="http://schemas.openxmlformats.org/drawingml/2006/main">
             <a:pPr algn="ctr">
+              <a:buNone/>
               <a:defRPr sz="1500" b="1" i="0">
                 <a:solidFill>
                   <a:srgbClr val="FFFFFF"/>
@@ -7219,6 +7308,7 @@
           <a:lstStyle xmlns:a="http://schemas.openxmlformats.org/drawingml/2006/main"/>
           <a:p xmlns:a="http://schemas.openxmlformats.org/drawingml/2006/main">
             <a:pPr algn="l">
+              <a:buNone/>
               <a:defRPr sz="1875" b="1" i="0">
                 <a:solidFill>
                   <a:srgbClr val="193B55"/>
@@ -7306,6 +7396,7 @@
           <a:lstStyle xmlns:a="http://schemas.openxmlformats.org/drawingml/2006/main"/>
           <a:p xmlns:a="http://schemas.openxmlformats.org/drawingml/2006/main">
             <a:pPr algn="ctr">
+              <a:buNone/>
               <a:defRPr sz="1500" b="1" i="0">
                 <a:solidFill>
                   <a:srgbClr val="FFFFFF"/>
@@ -7363,6 +7454,7 @@
           <a:lstStyle xmlns:a="http://schemas.openxmlformats.org/drawingml/2006/main"/>
           <a:p xmlns:a="http://schemas.openxmlformats.org/drawingml/2006/main">
             <a:pPr algn="l">
+              <a:buNone/>
               <a:defRPr sz="1875" b="1" i="0">
                 <a:solidFill>
                   <a:srgbClr val="193B55"/>
@@ -7450,6 +7542,7 @@
           <a:lstStyle xmlns:a="http://schemas.openxmlformats.org/drawingml/2006/main"/>
           <a:p xmlns:a="http://schemas.openxmlformats.org/drawingml/2006/main">
             <a:pPr algn="l">
+              <a:buNone/>
               <a:defRPr sz="1425" b="1" i="0">
                 <a:solidFill>
                   <a:srgbClr val="F4B52A"/>
@@ -7507,6 +7600,7 @@
           <a:lstStyle xmlns:a="http://schemas.openxmlformats.org/drawingml/2006/main"/>
           <a:p xmlns:a="http://schemas.openxmlformats.org/drawingml/2006/main">
             <a:pPr algn="ctr">
+              <a:buNone/>
               <a:defRPr sz="1650" b="1" i="0">
                 <a:solidFill>
                   <a:srgbClr val="193B55"/>
@@ -7623,6 +7717,7 @@
           <a:lstStyle xmlns:a="http://schemas.openxmlformats.org/drawingml/2006/main"/>
           <a:p xmlns:a="http://schemas.openxmlformats.org/drawingml/2006/main">
             <a:pPr algn="l">
+              <a:buNone/>
               <a:defRPr sz="2250" b="1" i="0">
                 <a:solidFill>
                   <a:srgbClr val="193B55"/>
@@ -7680,6 +7775,7 @@
           <a:lstStyle xmlns:a="http://schemas.openxmlformats.org/drawingml/2006/main"/>
           <a:p xmlns:a="http://schemas.openxmlformats.org/drawingml/2006/main">
             <a:pPr algn="l">
+              <a:buNone/>
               <a:defRPr sz="1125" b="0" i="0">
                 <a:solidFill>
                   <a:srgbClr val="60798D"/>
@@ -7737,6 +7833,7 @@
           <a:lstStyle xmlns:a="http://schemas.openxmlformats.org/drawingml/2006/main"/>
           <a:p xmlns:a="http://schemas.openxmlformats.org/drawingml/2006/main">
             <a:pPr algn="r">
+              <a:buNone/>
               <a:defRPr sz="900" b="1" i="0">
                 <a:solidFill>
                   <a:srgbClr val="168A6B"/>
@@ -7824,6 +7921,7 @@
           <a:lstStyle xmlns:a="http://schemas.openxmlformats.org/drawingml/2006/main"/>
           <a:p xmlns:a="http://schemas.openxmlformats.org/drawingml/2006/main">
             <a:pPr algn="l">
+              <a:buNone/>
               <a:defRPr sz="675" b="1" i="0">
                 <a:solidFill>
                   <a:srgbClr val="60798D"/>
@@ -7881,6 +7979,7 @@
           <a:lstStyle xmlns:a="http://schemas.openxmlformats.org/drawingml/2006/main"/>
           <a:p xmlns:a="http://schemas.openxmlformats.org/drawingml/2006/main">
             <a:pPr algn="r">
+              <a:buNone/>
               <a:defRPr sz="675" b="0" i="0">
                 <a:solidFill>
                   <a:srgbClr val="60798D"/>
@@ -7968,6 +8067,7 @@
           <a:lstStyle xmlns:a="http://schemas.openxmlformats.org/drawingml/2006/main"/>
           <a:p xmlns:a="http://schemas.openxmlformats.org/drawingml/2006/main">
             <a:pPr algn="ctr">
+              <a:buNone/>
               <a:defRPr sz="2325" b="1" i="0">
                 <a:solidFill>
                   <a:srgbClr val="193B55"/>
@@ -8055,6 +8155,7 @@
           <a:lstStyle xmlns:a="http://schemas.openxmlformats.org/drawingml/2006/main"/>
           <a:p xmlns:a="http://schemas.openxmlformats.org/drawingml/2006/main">
             <a:pPr algn="l">
+              <a:buNone/>
               <a:defRPr sz="1575" b="1" i="0">
                 <a:solidFill>
                   <a:srgbClr val="1777B4"/>
@@ -8112,6 +8213,7 @@
           <a:lstStyle xmlns:a="http://schemas.openxmlformats.org/drawingml/2006/main"/>
           <a:p xmlns:a="http://schemas.openxmlformats.org/drawingml/2006/main">
             <a:pPr algn="ctr">
+              <a:buNone/>
               <a:defRPr sz="2325" b="1" i="0">
                 <a:solidFill>
                   <a:srgbClr val="193B55"/>
@@ -8135,6 +8237,7 @@
           </a:p>
           <a:p xmlns:a="http://schemas.openxmlformats.org/drawingml/2006/main">
             <a:pPr algn="ctr">
+              <a:buNone/>
               <a:defRPr sz="2325" b="1" i="0">
                 <a:solidFill>
                   <a:srgbClr val="193B55"/>
@@ -8222,6 +8325,7 @@
           <a:lstStyle xmlns:a="http://schemas.openxmlformats.org/drawingml/2006/main"/>
           <a:p xmlns:a="http://schemas.openxmlformats.org/drawingml/2006/main">
             <a:pPr algn="l">
+              <a:buNone/>
               <a:defRPr sz="1575" b="1" i="0">
                 <a:solidFill>
                   <a:srgbClr val="168A6B"/>
@@ -8279,6 +8383,7 @@
           <a:lstStyle xmlns:a="http://schemas.openxmlformats.org/drawingml/2006/main"/>
           <a:p xmlns:a="http://schemas.openxmlformats.org/drawingml/2006/main">
             <a:pPr algn="ctr">
+              <a:buNone/>
               <a:defRPr sz="2175" b="1" i="0">
                 <a:solidFill>
                   <a:srgbClr val="193B55"/>
@@ -8302,6 +8407,7 @@
           </a:p>
           <a:p xmlns:a="http://schemas.openxmlformats.org/drawingml/2006/main">
             <a:pPr algn="ctr">
+              <a:buNone/>
               <a:defRPr sz="2175" b="1" i="0">
                 <a:solidFill>
                   <a:srgbClr val="193B55"/>
@@ -8359,6 +8465,7 @@
           <a:lstStyle xmlns:a="http://schemas.openxmlformats.org/drawingml/2006/main"/>
           <a:p xmlns:a="http://schemas.openxmlformats.org/drawingml/2006/main">
             <a:pPr algn="ctr">
+              <a:buNone/>
               <a:defRPr sz="1425" b="1" i="0">
                 <a:solidFill>
                   <a:srgbClr val="168A6B"/>
@@ -8475,6 +8582,7 @@
           <a:lstStyle xmlns:a="http://schemas.openxmlformats.org/drawingml/2006/main"/>
           <a:p xmlns:a="http://schemas.openxmlformats.org/drawingml/2006/main">
             <a:pPr algn="l">
+              <a:buNone/>
               <a:defRPr sz="2250" b="1" i="0">
                 <a:solidFill>
                   <a:srgbClr val="193B55"/>
@@ -8532,6 +8640,7 @@
           <a:lstStyle xmlns:a="http://schemas.openxmlformats.org/drawingml/2006/main"/>
           <a:p xmlns:a="http://schemas.openxmlformats.org/drawingml/2006/main">
             <a:pPr algn="l">
+              <a:buNone/>
               <a:defRPr sz="1125" b="0" i="0">
                 <a:solidFill>
                   <a:srgbClr val="60798D"/>
@@ -8589,6 +8698,7 @@
           <a:lstStyle xmlns:a="http://schemas.openxmlformats.org/drawingml/2006/main"/>
           <a:p xmlns:a="http://schemas.openxmlformats.org/drawingml/2006/main">
             <a:pPr algn="r">
+              <a:buNone/>
               <a:defRPr sz="900" b="1" i="0">
                 <a:solidFill>
                   <a:srgbClr val="E45D50"/>
@@ -8676,6 +8786,7 @@
           <a:lstStyle xmlns:a="http://schemas.openxmlformats.org/drawingml/2006/main"/>
           <a:p xmlns:a="http://schemas.openxmlformats.org/drawingml/2006/main">
             <a:pPr algn="l">
+              <a:buNone/>
               <a:defRPr sz="675" b="1" i="0">
                 <a:solidFill>
                   <a:srgbClr val="60798D"/>
@@ -8733,6 +8844,7 @@
           <a:lstStyle xmlns:a="http://schemas.openxmlformats.org/drawingml/2006/main"/>
           <a:p xmlns:a="http://schemas.openxmlformats.org/drawingml/2006/main">
             <a:pPr algn="r">
+              <a:buNone/>
               <a:defRPr sz="675" b="0" i="0">
                 <a:solidFill>
                   <a:srgbClr val="60798D"/>
@@ -8820,6 +8932,7 @@
           <a:lstStyle xmlns:a="http://schemas.openxmlformats.org/drawingml/2006/main"/>
           <a:p xmlns:a="http://schemas.openxmlformats.org/drawingml/2006/main">
             <a:pPr algn="ctr">
+              <a:buNone/>
               <a:defRPr sz="3000" b="1" i="0">
                 <a:solidFill>
                   <a:srgbClr val="FFFFFF"/>
@@ -8907,6 +9020,7 @@
           <a:lstStyle xmlns:a="http://schemas.openxmlformats.org/drawingml/2006/main"/>
           <a:p xmlns:a="http://schemas.openxmlformats.org/drawingml/2006/main">
             <a:pPr algn="l">
+              <a:buNone/>
               <a:defRPr sz="975" b="1" i="0">
                 <a:solidFill>
                   <a:srgbClr val="E45D50"/>
@@ -8964,6 +9078,7 @@
           <a:lstStyle xmlns:a="http://schemas.openxmlformats.org/drawingml/2006/main"/>
           <a:p xmlns:a="http://schemas.openxmlformats.org/drawingml/2006/main">
             <a:pPr algn="ctr">
+              <a:buNone/>
               <a:defRPr sz="2250" b="1" i="0">
                 <a:solidFill>
                   <a:srgbClr val="193B55"/>
@@ -9021,6 +9136,7 @@
           <a:lstStyle xmlns:a="http://schemas.openxmlformats.org/drawingml/2006/main"/>
           <a:p xmlns:a="http://schemas.openxmlformats.org/drawingml/2006/main">
             <a:pPr algn="ctr">
+              <a:buNone/>
               <a:defRPr sz="1875" b="1" i="0">
                 <a:solidFill>
                   <a:srgbClr val="E45D50"/>
@@ -9044,6 +9160,7 @@
           </a:p>
           <a:p xmlns:a="http://schemas.openxmlformats.org/drawingml/2006/main">
             <a:pPr algn="ctr">
+              <a:buNone/>
               <a:defRPr sz="1875" b="1" i="0">
                 <a:solidFill>
                   <a:srgbClr val="E45D50"/>
@@ -9131,6 +9248,7 @@
           <a:lstStyle xmlns:a="http://schemas.openxmlformats.org/drawingml/2006/main"/>
           <a:p xmlns:a="http://schemas.openxmlformats.org/drawingml/2006/main">
             <a:pPr algn="l">
+              <a:buNone/>
               <a:defRPr sz="975" b="1" i="0">
                 <a:solidFill>
                   <a:srgbClr val="F4B52A"/>
@@ -9188,6 +9306,7 @@
           <a:lstStyle xmlns:a="http://schemas.openxmlformats.org/drawingml/2006/main"/>
           <a:p xmlns:a="http://schemas.openxmlformats.org/drawingml/2006/main">
             <a:pPr algn="ctr">
+              <a:buNone/>
               <a:defRPr sz="2250" b="1" i="0">
                 <a:solidFill>
                   <a:srgbClr val="193B55"/>
@@ -9245,6 +9364,7 @@
           <a:lstStyle xmlns:a="http://schemas.openxmlformats.org/drawingml/2006/main"/>
           <a:p xmlns:a="http://schemas.openxmlformats.org/drawingml/2006/main">
             <a:pPr algn="ctr">
+              <a:buNone/>
               <a:defRPr sz="1800" b="1" i="0">
                 <a:solidFill>
                   <a:srgbClr val="193B55"/>
@@ -9268,6 +9388,7 @@
           </a:p>
           <a:p xmlns:a="http://schemas.openxmlformats.org/drawingml/2006/main">
             <a:pPr algn="ctr">
+              <a:buNone/>
               <a:defRPr sz="1800" b="1" i="0">
                 <a:solidFill>
                   <a:srgbClr val="193B55"/>
@@ -9325,6 +9446,7 @@
           <a:lstStyle xmlns:a="http://schemas.openxmlformats.org/drawingml/2006/main"/>
           <a:p xmlns:a="http://schemas.openxmlformats.org/drawingml/2006/main">
             <a:pPr algn="ctr">
+              <a:buNone/>
               <a:defRPr sz="1275" b="1" i="0">
                 <a:solidFill>
                   <a:srgbClr val="E45D50"/>
@@ -9441,6 +9563,7 @@
           <a:lstStyle xmlns:a="http://schemas.openxmlformats.org/drawingml/2006/main"/>
           <a:p xmlns:a="http://schemas.openxmlformats.org/drawingml/2006/main">
             <a:pPr algn="l">
+              <a:buNone/>
               <a:defRPr sz="2250" b="1" i="0">
                 <a:solidFill>
                   <a:srgbClr val="193B55"/>
@@ -9498,6 +9621,7 @@
           <a:lstStyle xmlns:a="http://schemas.openxmlformats.org/drawingml/2006/main"/>
           <a:p xmlns:a="http://schemas.openxmlformats.org/drawingml/2006/main">
             <a:pPr algn="l">
+              <a:buNone/>
               <a:defRPr sz="1125" b="0" i="0">
                 <a:solidFill>
                   <a:srgbClr val="60798D"/>
@@ -9516,7 +9640,7 @@
                 <a:ea typeface="Arial"/>
                 <a:cs typeface="Arial"/>
               </a:rPr>
-              <a:t>Complete the response before leaving.</a:t>
+              <a:t>Complete the response, then plan your next Unit 1C step.</a:t>
             </a:r>
           </a:p>
         </p:txBody>
@@ -9555,6 +9679,7 @@
           <a:lstStyle xmlns:a="http://schemas.openxmlformats.org/drawingml/2006/main"/>
           <a:p xmlns:a="http://schemas.openxmlformats.org/drawingml/2006/main">
             <a:pPr algn="r">
+              <a:buNone/>
               <a:defRPr sz="900" b="1" i="0">
                 <a:solidFill>
                   <a:srgbClr val="F4B52A"/>
@@ -9642,6 +9767,7 @@
           <a:lstStyle xmlns:a="http://schemas.openxmlformats.org/drawingml/2006/main"/>
           <a:p xmlns:a="http://schemas.openxmlformats.org/drawingml/2006/main">
             <a:pPr algn="l">
+              <a:buNone/>
               <a:defRPr sz="675" b="1" i="0">
                 <a:solidFill>
                   <a:srgbClr val="60798D"/>
@@ -9699,6 +9825,7 @@
           <a:lstStyle xmlns:a="http://schemas.openxmlformats.org/drawingml/2006/main"/>
           <a:p xmlns:a="http://schemas.openxmlformats.org/drawingml/2006/main">
             <a:pPr algn="r">
+              <a:buNone/>
               <a:defRPr sz="675" b="0" i="0">
                 <a:solidFill>
                   <a:srgbClr val="60798D"/>
@@ -9786,6 +9913,7 @@
           <a:lstStyle xmlns:a="http://schemas.openxmlformats.org/drawingml/2006/main"/>
           <a:p xmlns:a="http://schemas.openxmlformats.org/drawingml/2006/main">
             <a:pPr algn="l">
+              <a:buNone/>
               <a:defRPr sz="975" b="1" i="0">
                 <a:solidFill>
                   <a:srgbClr val="F4B52A"/>
@@ -9843,6 +9971,7 @@
           <a:lstStyle xmlns:a="http://schemas.openxmlformats.org/drawingml/2006/main"/>
           <a:p xmlns:a="http://schemas.openxmlformats.org/drawingml/2006/main">
             <a:pPr algn="ctr">
+              <a:buNone/>
               <a:defRPr sz="2100" b="1" i="0">
                 <a:solidFill>
                   <a:srgbClr val="FFFFFF"/>
@@ -9930,6 +10059,7 @@
           <a:lstStyle xmlns:a="http://schemas.openxmlformats.org/drawingml/2006/main"/>
           <a:p xmlns:a="http://schemas.openxmlformats.org/drawingml/2006/main">
             <a:pPr algn="ctr">
+              <a:buNone/>
               <a:defRPr sz="1500" b="1" i="0">
                 <a:solidFill>
                   <a:srgbClr val="FFFFFF"/>
@@ -9987,6 +10117,7 @@
           <a:lstStyle xmlns:a="http://schemas.openxmlformats.org/drawingml/2006/main"/>
           <a:p xmlns:a="http://schemas.openxmlformats.org/drawingml/2006/main">
             <a:pPr algn="l">
+              <a:buNone/>
               <a:defRPr sz="1725" b="1" i="0">
                 <a:solidFill>
                   <a:srgbClr val="193B55"/>
@@ -10005,7 +10136,7 @@
                 <a:ea typeface="Arial"/>
                 <a:cs typeface="Arial"/>
               </a:rPr>
-              <a:t>Continue Sections 2.1, 2.2, and 2.4 in ALEKS.</a:t>
+              <a:t>Open the course dashboard and continue Unit 1C.</a:t>
             </a:r>
           </a:p>
         </p:txBody>
@@ -10074,6 +10205,7 @@
           <a:lstStyle xmlns:a="http://schemas.openxmlformats.org/drawingml/2006/main"/>
           <a:p xmlns:a="http://schemas.openxmlformats.org/drawingml/2006/main">
             <a:pPr algn="ctr">
+              <a:buNone/>
               <a:defRPr sz="1500" b="1" i="0">
                 <a:solidFill>
                   <a:srgbClr val="FFFFFF"/>
@@ -10131,6 +10263,7 @@
           <a:lstStyle xmlns:a="http://schemas.openxmlformats.org/drawingml/2006/main"/>
           <a:p xmlns:a="http://schemas.openxmlformats.org/drawingml/2006/main">
             <a:pPr algn="l">
+              <a:buNone/>
               <a:defRPr sz="1725" b="1" i="0">
                 <a:solidFill>
                   <a:srgbClr val="193B55"/>
@@ -10149,7 +10282,7 @@
                 <a:ea typeface="Arial"/>
                 <a:cs typeface="Arial"/>
               </a:rPr>
-              <a:t>Finish distance and midpoint before moving to circle equations.</a:t>
+              <a:t>Finish ALEKS Sections 2.1, 2.2, and 2.4.</a:t>
             </a:r>
           </a:p>
         </p:txBody>
@@ -10218,6 +10351,7 @@
           <a:lstStyle xmlns:a="http://schemas.openxmlformats.org/drawingml/2006/main"/>
           <a:p xmlns:a="http://schemas.openxmlformats.org/drawingml/2006/main">
             <a:pPr algn="ctr">
+              <a:buNone/>
               <a:defRPr sz="1500" b="1" i="0">
                 <a:solidFill>
                   <a:srgbClr val="FFFFFF"/>
@@ -10275,6 +10409,7 @@
           <a:lstStyle xmlns:a="http://schemas.openxmlformats.org/drawingml/2006/main"/>
           <a:p xmlns:a="http://schemas.openxmlformats.org/drawingml/2006/main">
             <a:pPr algn="l">
+              <a:buNone/>
               <a:defRPr sz="1725" b="1" i="0">
                 <a:solidFill>
                   <a:srgbClr val="193B55"/>
@@ -10293,7 +10428,7 @@
                 <a:ea typeface="Arial"/>
                 <a:cs typeface="Arial"/>
               </a:rPr>
-              <a:t>Check Canvas for the exact Quiz 3 deadline.</a:t>
+              <a:t>Use Unit 1C practice and the checkpoint before Quiz 3.</a:t>
             </a:r>
           </a:p>
         </p:txBody>
@@ -10362,6 +10497,7 @@
           <a:lstStyle xmlns:a="http://schemas.openxmlformats.org/drawingml/2006/main"/>
           <a:p xmlns:a="http://schemas.openxmlformats.org/drawingml/2006/main">
             <a:pPr algn="ctr">
+              <a:buNone/>
               <a:defRPr sz="1350" b="1" i="0">
                 <a:solidFill>
                   <a:srgbClr val="193B55"/>
@@ -10478,6 +10614,7 @@
           <a:lstStyle xmlns:a="http://schemas.openxmlformats.org/drawingml/2006/main"/>
           <a:p xmlns:a="http://schemas.openxmlformats.org/drawingml/2006/main">
             <a:pPr algn="l">
+              <a:buNone/>
               <a:defRPr sz="2250" b="1" i="0">
                 <a:solidFill>
                   <a:srgbClr val="193B55"/>
@@ -10535,6 +10672,7 @@
           <a:lstStyle xmlns:a="http://schemas.openxmlformats.org/drawingml/2006/main"/>
           <a:p xmlns:a="http://schemas.openxmlformats.org/drawingml/2006/main">
             <a:pPr algn="l">
+              <a:buNone/>
               <a:defRPr sz="1125" b="0" i="0">
                 <a:solidFill>
                   <a:srgbClr val="60798D"/>
@@ -10553,7 +10691,7 @@
                 <a:ea typeface="Arial"/>
                 <a:cs typeface="Arial"/>
               </a:rPr>
-              <a:t>A full class for Sections 2.1, 2.2, and 2.4</a:t>
+              <a:t>Course website, then Sections 2.1, 2.2, and 2.4</a:t>
             </a:r>
           </a:p>
         </p:txBody>
@@ -10592,6 +10730,7 @@
           <a:lstStyle xmlns:a="http://schemas.openxmlformats.org/drawingml/2006/main"/>
           <a:p xmlns:a="http://schemas.openxmlformats.org/drawingml/2006/main">
             <a:pPr algn="r">
+              <a:buNone/>
               <a:defRPr sz="900" b="1" i="0">
                 <a:solidFill>
                   <a:srgbClr val="1777B4"/>
@@ -10679,6 +10818,7 @@
           <a:lstStyle xmlns:a="http://schemas.openxmlformats.org/drawingml/2006/main"/>
           <a:p xmlns:a="http://schemas.openxmlformats.org/drawingml/2006/main">
             <a:pPr algn="l">
+              <a:buNone/>
               <a:defRPr sz="675" b="1" i="0">
                 <a:solidFill>
                   <a:srgbClr val="60798D"/>
@@ -10736,6 +10876,7 @@
           <a:lstStyle xmlns:a="http://schemas.openxmlformats.org/drawingml/2006/main"/>
           <a:p xmlns:a="http://schemas.openxmlformats.org/drawingml/2006/main">
             <a:pPr algn="r">
+              <a:buNone/>
               <a:defRPr sz="675" b="0" i="0">
                 <a:solidFill>
                   <a:srgbClr val="60798D"/>
@@ -10823,6 +10964,7 @@
           <a:lstStyle xmlns:a="http://schemas.openxmlformats.org/drawingml/2006/main"/>
           <a:p xmlns:a="http://schemas.openxmlformats.org/drawingml/2006/main">
             <a:pPr algn="ctr">
+              <a:buNone/>
               <a:defRPr sz="1050" b="1" i="0">
                 <a:solidFill>
                   <a:srgbClr val="FFFFFF"/>
@@ -10880,6 +11022,7 @@
           <a:lstStyle xmlns:a="http://schemas.openxmlformats.org/drawingml/2006/main"/>
           <a:p xmlns:a="http://schemas.openxmlformats.org/drawingml/2006/main">
             <a:pPr algn="ctr">
+              <a:buNone/>
               <a:defRPr sz="675" b="0" i="0">
                 <a:solidFill>
                   <a:srgbClr val="FFFFFF"/>
@@ -10937,6 +11080,7 @@
           <a:lstStyle xmlns:a="http://schemas.openxmlformats.org/drawingml/2006/main"/>
           <a:p xmlns:a="http://schemas.openxmlformats.org/drawingml/2006/main">
             <a:pPr algn="ctr">
+              <a:buNone/>
               <a:defRPr sz="1050" b="1" i="0">
                 <a:solidFill>
                   <a:srgbClr val="193B55"/>
@@ -10955,7 +11099,7 @@
                 <a:ea typeface="Arial"/>
                 <a:cs typeface="Arial"/>
               </a:rPr>
-              <a:t>Launch</a:t>
+              <a:t>Course site</a:t>
             </a:r>
           </a:p>
         </p:txBody>
@@ -11024,6 +11168,7 @@
           <a:lstStyle xmlns:a="http://schemas.openxmlformats.org/drawingml/2006/main"/>
           <a:p xmlns:a="http://schemas.openxmlformats.org/drawingml/2006/main">
             <a:pPr algn="ctr">
+              <a:buNone/>
               <a:defRPr sz="1500" b="1" i="0">
                 <a:solidFill>
                   <a:srgbClr val="FFFFFF"/>
@@ -11081,6 +11226,7 @@
           <a:lstStyle xmlns:a="http://schemas.openxmlformats.org/drawingml/2006/main"/>
           <a:p xmlns:a="http://schemas.openxmlformats.org/drawingml/2006/main">
             <a:pPr algn="ctr">
+              <a:buNone/>
               <a:defRPr sz="975" b="0" i="0">
                 <a:solidFill>
                   <a:srgbClr val="FFFFFF"/>
@@ -11138,6 +11284,7 @@
           <a:lstStyle xmlns:a="http://schemas.openxmlformats.org/drawingml/2006/main"/>
           <a:p xmlns:a="http://schemas.openxmlformats.org/drawingml/2006/main">
             <a:pPr algn="ctr">
+              <a:buNone/>
               <a:defRPr sz="1425" b="1" i="0">
                 <a:solidFill>
                   <a:srgbClr val="193B55"/>
@@ -11225,6 +11372,7 @@
           <a:lstStyle xmlns:a="http://schemas.openxmlformats.org/drawingml/2006/main"/>
           <a:p xmlns:a="http://schemas.openxmlformats.org/drawingml/2006/main">
             <a:pPr algn="ctr">
+              <a:buNone/>
               <a:defRPr sz="1500" b="1" i="0">
                 <a:solidFill>
                   <a:srgbClr val="FFFFFF"/>
@@ -11282,6 +11430,7 @@
           <a:lstStyle xmlns:a="http://schemas.openxmlformats.org/drawingml/2006/main"/>
           <a:p xmlns:a="http://schemas.openxmlformats.org/drawingml/2006/main">
             <a:pPr algn="ctr">
+              <a:buNone/>
               <a:defRPr sz="975" b="0" i="0">
                 <a:solidFill>
                   <a:srgbClr val="FFFFFF"/>
@@ -11339,6 +11488,7 @@
           <a:lstStyle xmlns:a="http://schemas.openxmlformats.org/drawingml/2006/main"/>
           <a:p xmlns:a="http://schemas.openxmlformats.org/drawingml/2006/main">
             <a:pPr algn="ctr">
+              <a:buNone/>
               <a:defRPr sz="1425" b="1" i="0">
                 <a:solidFill>
                   <a:srgbClr val="193B55"/>
@@ -11426,6 +11576,7 @@
           <a:lstStyle xmlns:a="http://schemas.openxmlformats.org/drawingml/2006/main"/>
           <a:p xmlns:a="http://schemas.openxmlformats.org/drawingml/2006/main">
             <a:pPr algn="ctr">
+              <a:buNone/>
               <a:defRPr sz="1500" b="1" i="0">
                 <a:solidFill>
                   <a:srgbClr val="FFFFFF"/>
@@ -11483,6 +11634,7 @@
           <a:lstStyle xmlns:a="http://schemas.openxmlformats.org/drawingml/2006/main"/>
           <a:p xmlns:a="http://schemas.openxmlformats.org/drawingml/2006/main">
             <a:pPr algn="ctr">
+              <a:buNone/>
               <a:defRPr sz="975" b="0" i="0">
                 <a:solidFill>
                   <a:srgbClr val="FFFFFF"/>
@@ -11540,6 +11692,7 @@
           <a:lstStyle xmlns:a="http://schemas.openxmlformats.org/drawingml/2006/main"/>
           <a:p xmlns:a="http://schemas.openxmlformats.org/drawingml/2006/main">
             <a:pPr algn="ctr">
+              <a:buNone/>
               <a:defRPr sz="1425" b="1" i="0">
                 <a:solidFill>
                   <a:srgbClr val="193B55"/>
@@ -11627,6 +11780,7 @@
           <a:lstStyle xmlns:a="http://schemas.openxmlformats.org/drawingml/2006/main"/>
           <a:p xmlns:a="http://schemas.openxmlformats.org/drawingml/2006/main">
             <a:pPr algn="ctr">
+              <a:buNone/>
               <a:defRPr sz="1050" b="1" i="0">
                 <a:solidFill>
                   <a:srgbClr val="FFFFFF"/>
@@ -11684,6 +11838,7 @@
           <a:lstStyle xmlns:a="http://schemas.openxmlformats.org/drawingml/2006/main"/>
           <a:p xmlns:a="http://schemas.openxmlformats.org/drawingml/2006/main">
             <a:pPr algn="ctr">
+              <a:buNone/>
               <a:defRPr sz="675" b="0" i="0">
                 <a:solidFill>
                   <a:srgbClr val="FFFFFF"/>
@@ -11741,6 +11896,7 @@
           <a:lstStyle xmlns:a="http://schemas.openxmlformats.org/drawingml/2006/main"/>
           <a:p xmlns:a="http://schemas.openxmlformats.org/drawingml/2006/main">
             <a:pPr algn="ctr">
+              <a:buNone/>
               <a:defRPr sz="1050" b="1" i="0">
                 <a:solidFill>
                   <a:srgbClr val="193B55"/>
@@ -11828,6 +11984,7 @@
           <a:lstStyle xmlns:a="http://schemas.openxmlformats.org/drawingml/2006/main"/>
           <a:p xmlns:a="http://schemas.openxmlformats.org/drawingml/2006/main">
             <a:pPr algn="ctr">
+              <a:buNone/>
               <a:defRPr sz="2550" b="1" i="0">
                 <a:solidFill>
                   <a:srgbClr val="F4B52A"/>
@@ -11885,6 +12042,7 @@
           <a:lstStyle xmlns:a="http://schemas.openxmlformats.org/drawingml/2006/main"/>
           <a:p xmlns:a="http://schemas.openxmlformats.org/drawingml/2006/main">
             <a:pPr algn="l">
+              <a:buNone/>
               <a:defRPr sz="2175" b="1" i="0">
                 <a:solidFill>
                   <a:srgbClr val="193B55"/>
@@ -11942,6 +12100,7 @@
           <a:lstStyle xmlns:a="http://schemas.openxmlformats.org/drawingml/2006/main"/>
           <a:p xmlns:a="http://schemas.openxmlformats.org/drawingml/2006/main">
             <a:pPr algn="ctr">
+              <a:buNone/>
               <a:defRPr sz="1200" b="0" i="0">
                 <a:solidFill>
                   <a:srgbClr val="60798D"/>
@@ -11999,6 +12158,7 @@
           <a:lstStyle xmlns:a="http://schemas.openxmlformats.org/drawingml/2006/main"/>
           <a:p xmlns:a="http://schemas.openxmlformats.org/drawingml/2006/main">
             <a:pPr algn="l">
+              <a:buNone/>
               <a:defRPr sz="1275" b="0" i="0">
                 <a:solidFill>
                   <a:srgbClr val="60798D"/>
@@ -12115,6 +12275,7 @@
           <a:lstStyle xmlns:a="http://schemas.openxmlformats.org/drawingml/2006/main"/>
           <a:p xmlns:a="http://schemas.openxmlformats.org/drawingml/2006/main">
             <a:pPr algn="l">
+              <a:buNone/>
               <a:defRPr sz="2250" b="1" i="0">
                 <a:solidFill>
                   <a:srgbClr val="193B55"/>
@@ -12133,7 +12294,7 @@
                 <a:ea typeface="Arial"/>
                 <a:cs typeface="Arial"/>
               </a:rPr>
-              <a:t>Current module priorities</a:t>
+              <a:t>Course website and current priorities</a:t>
             </a:r>
           </a:p>
         </p:txBody>
@@ -12172,6 +12333,7 @@
           <a:lstStyle xmlns:a="http://schemas.openxmlformats.org/drawingml/2006/main"/>
           <a:p xmlns:a="http://schemas.openxmlformats.org/drawingml/2006/main">
             <a:pPr algn="l">
+              <a:buNone/>
               <a:defRPr sz="1125" b="0" i="0">
                 <a:solidFill>
                   <a:srgbClr val="60798D"/>
@@ -12190,7 +12352,7 @@
                 <a:ea typeface="Arial"/>
                 <a:cs typeface="Arial"/>
               </a:rPr>
-              <a:t>Ready to learn in the September 9 ALEKS report</a:t>
+              <a:t>The updated dashboard keeps this week’s Unit 1C work together</a:t>
             </a:r>
           </a:p>
         </p:txBody>
@@ -12229,6 +12391,7 @@
           <a:lstStyle xmlns:a="http://schemas.openxmlformats.org/drawingml/2006/main"/>
           <a:p xmlns:a="http://schemas.openxmlformats.org/drawingml/2006/main">
             <a:pPr algn="r">
+              <a:buNone/>
               <a:defRPr sz="900" b="1" i="0">
                 <a:solidFill>
                   <a:srgbClr val="1777B4"/>
@@ -12247,7 +12410,7 @@
                 <a:ea typeface="Arial"/>
                 <a:cs typeface="Arial"/>
               </a:rPr>
-              <a:t>TARGET</a:t>
+              <a:t>THIS WEEK</a:t>
             </a:r>
           </a:p>
         </p:txBody>
@@ -12316,6 +12479,7 @@
           <a:lstStyle xmlns:a="http://schemas.openxmlformats.org/drawingml/2006/main"/>
           <a:p xmlns:a="http://schemas.openxmlformats.org/drawingml/2006/main">
             <a:pPr algn="l">
+              <a:buNone/>
               <a:defRPr sz="675" b="1" i="0">
                 <a:solidFill>
                   <a:srgbClr val="60798D"/>
@@ -12373,6 +12537,7 @@
           <a:lstStyle xmlns:a="http://schemas.openxmlformats.org/drawingml/2006/main"/>
           <a:p xmlns:a="http://schemas.openxmlformats.org/drawingml/2006/main">
             <a:pPr algn="r">
+              <a:buNone/>
               <a:defRPr sz="675" b="0" i="0">
                 <a:solidFill>
                   <a:srgbClr val="60798D"/>
@@ -12392,13 +12557,377 @@
                 <a:cs typeface="Arial"/>
               </a:rPr>
               <a:t>3  slide</a:t>
+            </a:r>
+          </a:p>
+        </p:txBody>
+      </p:sp>
+      <p:sp>
+        <p:nvSpPr>
+          <p:cNvPr id="9" name="">
+            <a:extLst xmlns:a="http://schemas.openxmlformats.org/drawingml/2006/main">
+              <a:ext uri="{FF2B5EF4-FFF2-40B4-BE49-F238E27FC236}">
+                <a16:creationId xmlns:a16="http://schemas.microsoft.com/office/drawing/2014/main" id="{9B724B6A-BE86-41C0-B1EF-2BBFAD165821}"/>
+              </a:ext>
+            </a:extLst>
+          </p:cNvPr>
+          <p:cNvSpPr>
+            <a:spLocks xmlns:a="http://schemas.openxmlformats.org/drawingml/2006/main" noGrp="1"/>
+          </p:cNvSpPr>
+          <p:nvPr/>
+        </p:nvSpPr>
+        <p:spPr>
+          <a:xfrm xmlns:a="http://schemas.openxmlformats.org/drawingml/2006/main">
+            <a:off x="7962900" y="1657350"/>
+            <a:ext cx="3505200" cy="1581150"/>
+          </a:xfrm>
+          <a:prstGeom xmlns:a="http://schemas.openxmlformats.org/drawingml/2006/main" prst="rect">
+            <a:avLst/>
+          </a:prstGeom>
+          <a:solidFill xmlns:a="http://schemas.openxmlformats.org/drawingml/2006/main">
+            <a:srgbClr val="102F49"/>
+          </a:solidFill>
+          <a:ln xmlns:a="http://schemas.openxmlformats.org/drawingml/2006/main" w="0">
+            <a:noFill/>
+          </a:ln>
+        </p:spPr>
+      </p:sp>
+      <p:sp>
+        <p:nvSpPr>
+          <p:cNvPr id="10" name="">
+            <a:extLst xmlns:a="http://schemas.openxmlformats.org/drawingml/2006/main">
+              <a:ext uri="{FF2B5EF4-FFF2-40B4-BE49-F238E27FC236}">
+                <a16:creationId xmlns:a16="http://schemas.microsoft.com/office/drawing/2014/main" id="{8425B898-C7C8-4B7D-B9D5-6AC741F7EE22}"/>
+              </a:ext>
+            </a:extLst>
+          </p:cNvPr>
+          <p:cNvSpPr>
+            <a:spLocks xmlns:a="http://schemas.openxmlformats.org/drawingml/2006/main" noGrp="1"/>
+          </p:cNvSpPr>
+          <p:nvPr/>
+        </p:nvSpPr>
+        <p:spPr>
+          <a:xfrm xmlns:a="http://schemas.openxmlformats.org/drawingml/2006/main">
+            <a:off x="8267700" y="1790700"/>
+            <a:ext cx="2895600" cy="762000"/>
+          </a:xfrm>
+          <a:prstGeom xmlns:a="http://schemas.openxmlformats.org/drawingml/2006/main" prst="rect">
+            <a:avLst/>
+          </a:prstGeom>
+          <a:noFill xmlns:a="http://schemas.openxmlformats.org/drawingml/2006/main"/>
+          <a:ln xmlns:a="http://schemas.openxmlformats.org/drawingml/2006/main" w="0">
+            <a:noFill/>
+          </a:ln>
+        </p:spPr>
+        <p:txBody>
+          <a:bodyPr xmlns:a="http://schemas.openxmlformats.org/drawingml/2006/main" anchor="ctr">
+            <a:noAutofit/>
+          </a:bodyPr>
+          <a:lstStyle xmlns:a="http://schemas.openxmlformats.org/drawingml/2006/main"/>
+          <a:p xmlns:a="http://schemas.openxmlformats.org/drawingml/2006/main">
+            <a:pPr algn="ctr">
+              <a:buNone/>
+              <a:defRPr sz="4650" b="1" i="0">
+                <a:solidFill>
+                  <a:srgbClr val="F4B52A"/>
+                </a:solidFill>
+                <a:latin typeface="Arial"/>
+                <a:ea typeface="Arial"/>
+                <a:cs typeface="Arial"/>
+              </a:defRPr>
+            </a:pPr>
+            <a:r>
+              <a:rPr sz="4650" b="1" i="0">
+                <a:solidFill>
+                  <a:srgbClr val="F4B52A"/>
+                </a:solidFill>
+                <a:latin typeface="Arial"/>
+                <a:ea typeface="Arial"/>
+                <a:cs typeface="Arial"/>
+              </a:rPr>
+              <a:t>36%</a:t>
+            </a:r>
+          </a:p>
+        </p:txBody>
+      </p:sp>
+      <p:sp>
+        <p:nvSpPr>
+          <p:cNvPr id="11" name="">
+            <a:extLst xmlns:a="http://schemas.openxmlformats.org/drawingml/2006/main">
+              <a:ext uri="{FF2B5EF4-FFF2-40B4-BE49-F238E27FC236}">
+                <a16:creationId xmlns:a16="http://schemas.microsoft.com/office/drawing/2014/main" id="{094A58A1-4CBA-4ECB-A04A-FE9D633A1356}"/>
+              </a:ext>
+            </a:extLst>
+          </p:cNvPr>
+          <p:cNvSpPr>
+            <a:spLocks xmlns:a="http://schemas.openxmlformats.org/drawingml/2006/main" noGrp="1"/>
+          </p:cNvSpPr>
+          <p:nvPr/>
+        </p:nvSpPr>
+        <p:spPr>
+          <a:xfrm xmlns:a="http://schemas.openxmlformats.org/drawingml/2006/main">
+            <a:off x="8267700" y="2571750"/>
+            <a:ext cx="2895600" cy="400050"/>
+          </a:xfrm>
+          <a:prstGeom xmlns:a="http://schemas.openxmlformats.org/drawingml/2006/main" prst="rect">
+            <a:avLst/>
+          </a:prstGeom>
+          <a:noFill xmlns:a="http://schemas.openxmlformats.org/drawingml/2006/main"/>
+          <a:ln xmlns:a="http://schemas.openxmlformats.org/drawingml/2006/main" w="0">
+            <a:noFill/>
+          </a:ln>
+        </p:spPr>
+        <p:txBody>
+          <a:bodyPr xmlns:a="http://schemas.openxmlformats.org/drawingml/2006/main" anchor="ctr">
+            <a:noAutofit/>
+          </a:bodyPr>
+          <a:lstStyle xmlns:a="http://schemas.openxmlformats.org/drawingml/2006/main"/>
+          <a:p xmlns:a="http://schemas.openxmlformats.org/drawingml/2006/main">
+            <a:pPr algn="ctr">
+              <a:buNone/>
+              <a:defRPr sz="1275" b="1" i="0">
+                <a:solidFill>
+                  <a:srgbClr val="FFFFFF"/>
+                </a:solidFill>
+                <a:latin typeface="Arial"/>
+                <a:ea typeface="Arial"/>
+                <a:cs typeface="Arial"/>
+              </a:defRPr>
+            </a:pPr>
+            <a:r>
+              <a:rPr sz="1275" b="1" i="0">
+                <a:solidFill>
+                  <a:srgbClr val="FFFFFF"/>
+                </a:solidFill>
+                <a:latin typeface="Arial"/>
+                <a:ea typeface="Arial"/>
+                <a:cs typeface="Arial"/>
+              </a:rPr>
+              <a:t>average current-module progress</a:t>
+            </a:r>
+          </a:p>
+        </p:txBody>
+      </p:sp>
+      <p:sp>
+        <p:nvSpPr>
+          <p:cNvPr id="12" name="">
+            <a:extLst xmlns:a="http://schemas.openxmlformats.org/drawingml/2006/main">
+              <a:ext uri="{FF2B5EF4-FFF2-40B4-BE49-F238E27FC236}">
+                <a16:creationId xmlns:a16="http://schemas.microsoft.com/office/drawing/2014/main" id="{48092BC2-C5D9-443D-B17C-FC19E949D12B}"/>
+              </a:ext>
+            </a:extLst>
+          </p:cNvPr>
+          <p:cNvSpPr>
+            <a:spLocks xmlns:a="http://schemas.openxmlformats.org/drawingml/2006/main" noGrp="1"/>
+          </p:cNvSpPr>
+          <p:nvPr/>
+        </p:nvSpPr>
+        <p:spPr>
+          <a:xfrm xmlns:a="http://schemas.openxmlformats.org/drawingml/2006/main">
+            <a:off x="7962900" y="3524250"/>
+            <a:ext cx="3505200" cy="2000250"/>
+          </a:xfrm>
+          <a:prstGeom xmlns:a="http://schemas.openxmlformats.org/drawingml/2006/main" prst="rect">
+            <a:avLst/>
+          </a:prstGeom>
+          <a:solidFill xmlns:a="http://schemas.openxmlformats.org/drawingml/2006/main">
+            <a:srgbClr val="E4F4EF"/>
+          </a:solidFill>
+          <a:ln xmlns:a="http://schemas.openxmlformats.org/drawingml/2006/main" w="0">
+            <a:noFill/>
+          </a:ln>
+        </p:spPr>
+      </p:sp>
+      <p:sp>
+        <p:nvSpPr>
+          <p:cNvPr id="13" name="">
+            <a:extLst xmlns:a="http://schemas.openxmlformats.org/drawingml/2006/main">
+              <a:ext uri="{FF2B5EF4-FFF2-40B4-BE49-F238E27FC236}">
+                <a16:creationId xmlns:a16="http://schemas.microsoft.com/office/drawing/2014/main" id="{C5FFB3AA-6816-462C-B26B-C22A6087915A}"/>
+              </a:ext>
+            </a:extLst>
+          </p:cNvPr>
+          <p:cNvSpPr>
+            <a:spLocks xmlns:a="http://schemas.openxmlformats.org/drawingml/2006/main" noGrp="1"/>
+          </p:cNvSpPr>
+          <p:nvPr/>
+        </p:nvSpPr>
+        <p:spPr>
+          <a:xfrm xmlns:a="http://schemas.openxmlformats.org/drawingml/2006/main">
+            <a:off x="8248650" y="3695700"/>
+            <a:ext cx="2933700" cy="323850"/>
+          </a:xfrm>
+          <a:prstGeom xmlns:a="http://schemas.openxmlformats.org/drawingml/2006/main" prst="rect">
+            <a:avLst/>
+          </a:prstGeom>
+          <a:noFill xmlns:a="http://schemas.openxmlformats.org/drawingml/2006/main"/>
+          <a:ln xmlns:a="http://schemas.openxmlformats.org/drawingml/2006/main" w="0">
+            <a:noFill/>
+          </a:ln>
+        </p:spPr>
+        <p:txBody>
+          <a:bodyPr xmlns:a="http://schemas.openxmlformats.org/drawingml/2006/main" anchor="ctr">
+            <a:noAutofit/>
+          </a:bodyPr>
+          <a:lstStyle xmlns:a="http://schemas.openxmlformats.org/drawingml/2006/main"/>
+          <a:p xmlns:a="http://schemas.openxmlformats.org/drawingml/2006/main">
+            <a:pPr algn="l">
+              <a:buNone/>
+              <a:defRPr sz="1650" b="1" i="0">
+                <a:solidFill>
+                  <a:srgbClr val="168A6B"/>
+                </a:solidFill>
+                <a:latin typeface="Arial"/>
+                <a:ea typeface="Arial"/>
+                <a:cs typeface="Arial"/>
+              </a:defRPr>
+            </a:pPr>
+            <a:r>
+              <a:rPr sz="1650" b="1" i="0">
+                <a:solidFill>
+                  <a:srgbClr val="168A6B"/>
+                </a:solidFill>
+                <a:latin typeface="Arial"/>
+                <a:ea typeface="Arial"/>
+                <a:cs typeface="Arial"/>
+              </a:rPr>
+              <a:t>This week on the site</a:t>
+            </a:r>
+          </a:p>
+        </p:txBody>
+      </p:sp>
+      <p:sp>
+        <p:nvSpPr>
+          <p:cNvPr id="14" name="">
+            <a:extLst xmlns:a="http://schemas.openxmlformats.org/drawingml/2006/main">
+              <a:ext uri="{FF2B5EF4-FFF2-40B4-BE49-F238E27FC236}">
+                <a16:creationId xmlns:a16="http://schemas.microsoft.com/office/drawing/2014/main" id="{C71E1065-B9A1-438F-B76E-8F78526AD27F}"/>
+              </a:ext>
+            </a:extLst>
+          </p:cNvPr>
+          <p:cNvSpPr>
+            <a:spLocks xmlns:a="http://schemas.openxmlformats.org/drawingml/2006/main" noGrp="1"/>
+          </p:cNvSpPr>
+          <p:nvPr/>
+        </p:nvSpPr>
+        <p:spPr>
+          <a:xfrm xmlns:a="http://schemas.openxmlformats.org/drawingml/2006/main">
+            <a:off x="8248650" y="4076700"/>
+            <a:ext cx="2933700" cy="1219200"/>
+          </a:xfrm>
+          <a:prstGeom xmlns:a="http://schemas.openxmlformats.org/drawingml/2006/main" prst="rect">
+            <a:avLst/>
+          </a:prstGeom>
+          <a:noFill xmlns:a="http://schemas.openxmlformats.org/drawingml/2006/main"/>
+          <a:ln xmlns:a="http://schemas.openxmlformats.org/drawingml/2006/main" w="0">
+            <a:noFill/>
+          </a:ln>
+        </p:spPr>
+        <p:txBody>
+          <a:bodyPr xmlns:a="http://schemas.openxmlformats.org/drawingml/2006/main" anchor="t">
+            <a:noAutofit/>
+          </a:bodyPr>
+          <a:lstStyle xmlns:a="http://schemas.openxmlformats.org/drawingml/2006/main"/>
+          <a:p xmlns:a="http://schemas.openxmlformats.org/drawingml/2006/main">
+            <a:pPr algn="l">
+              <a:buNone/>
+              <a:defRPr sz="1500" b="1" i="0">
+                <a:solidFill>
+                  <a:srgbClr val="193B55"/>
+                </a:solidFill>
+                <a:latin typeface="Arial"/>
+                <a:ea typeface="Arial"/>
+                <a:cs typeface="Arial"/>
+              </a:defRPr>
+            </a:pPr>
+            <a:r>
+              <a:rPr sz="1500" b="1" i="0">
+                <a:solidFill>
+                  <a:srgbClr val="193B55"/>
+                </a:solidFill>
+                <a:latin typeface="Arial"/>
+                <a:ea typeface="Arial"/>
+                <a:cs typeface="Arial"/>
+              </a:rPr>
+              <a:t>Courses / MATH 130</a:t>
+            </a:r>
+          </a:p>
+          <a:p xmlns:a="http://schemas.openxmlformats.org/drawingml/2006/main">
+            <a:pPr algn="l">
+              <a:buNone/>
+              <a:defRPr sz="1500" b="1" i="0">
+                <a:solidFill>
+                  <a:srgbClr val="193B55"/>
+                </a:solidFill>
+                <a:latin typeface="Arial"/>
+                <a:ea typeface="Arial"/>
+                <a:cs typeface="Arial"/>
+              </a:defRPr>
+            </a:pPr>
+            <a:r>
+              <a:rPr sz="1500" b="1" i="0">
+                <a:solidFill>
+                  <a:srgbClr val="193B55"/>
+                </a:solidFill>
+                <a:latin typeface="Arial"/>
+                <a:ea typeface="Arial"/>
+                <a:cs typeface="Arial"/>
+              </a:rPr>
+              <a:t>Plan and Learn: Unit 1C</a:t>
+            </a:r>
+          </a:p>
+          <a:p xmlns:a="http://schemas.openxmlformats.org/drawingml/2006/main">
+            <a:pPr algn="l">
+              <a:buNone/>
+              <a:defRPr sz="1500" b="1" i="0">
+                <a:solidFill>
+                  <a:srgbClr val="193B55"/>
+                </a:solidFill>
+                <a:latin typeface="Arial"/>
+                <a:ea typeface="Arial"/>
+                <a:cs typeface="Arial"/>
+              </a:defRPr>
+            </a:pPr>
+            <a:r>
+              <a:rPr sz="1500" b="1" i="0">
+                <a:solidFill>
+                  <a:srgbClr val="193B55"/>
+                </a:solidFill>
+                <a:latin typeface="Arial"/>
+                <a:ea typeface="Arial"/>
+                <a:cs typeface="Arial"/>
+              </a:rPr>
+              <a:t>Practice: current skills</a:t>
+            </a:r>
+          </a:p>
+          <a:p xmlns:a="http://schemas.openxmlformats.org/drawingml/2006/main">
+            <a:pPr algn="l">
+              <a:buNone/>
+              <a:defRPr sz="1500" b="1" i="0">
+                <a:solidFill>
+                  <a:srgbClr val="193B55"/>
+                </a:solidFill>
+                <a:latin typeface="Arial"/>
+                <a:ea typeface="Arial"/>
+                <a:cs typeface="Arial"/>
+              </a:defRPr>
+            </a:pPr>
+            <a:r>
+              <a:rPr sz="1500" b="1" i="0">
+                <a:solidFill>
+                  <a:srgbClr val="193B55"/>
+                </a:solidFill>
+                <a:latin typeface="Arial"/>
+                <a:ea typeface="Arial"/>
+                <a:cs typeface="Arial"/>
+              </a:rPr>
+              <a:t>Progress: Quiz 3 checkpoint</a:t>
             </a:r>
           </a:p>
         </p:txBody>
       </p:sp>
       <p:graphicFrame>
         <p:nvGraphicFramePr>
-          <p:cNvPr id="22" name="Chart"/>
+          <p:cNvPr id="30" name="Chart"/>
           <p:cNvGraphicFramePr/>
           <p:nvPr/>
         </p:nvGraphicFramePr>
@@ -12408,367 +12937,10 @@
         </p:xfrm>
         <a:graphic xmlns:a="http://schemas.openxmlformats.org/drawingml/2006/main">
           <a:graphicData uri="http://schemas.openxmlformats.org/drawingml/2006/chart">
-            <c:chart xmlns:r="http://schemas.openxmlformats.org/officeDocument/2006/relationships" xmlns:c="http://schemas.openxmlformats.org/drawingml/2006/chart" r:id="R1a40523ee0d64f42"/>
+            <c:chart xmlns:r="http://schemas.openxmlformats.org/officeDocument/2006/relationships" xmlns:c="http://schemas.openxmlformats.org/drawingml/2006/chart" r:id="Rb8e405e4d852400f"/>
           </a:graphicData>
         </a:graphic>
       </p:graphicFrame>
-      <p:sp>
-        <p:nvSpPr>
-          <p:cNvPr id="9" name="">
-            <a:extLst xmlns:a="http://schemas.openxmlformats.org/drawingml/2006/main">
-              <a:ext uri="{FF2B5EF4-FFF2-40B4-BE49-F238E27FC236}">
-                <a16:creationId xmlns:a16="http://schemas.microsoft.com/office/drawing/2014/main" id="{9B724B6A-BE86-41C0-B1EF-2BBFAD165821}"/>
-              </a:ext>
-            </a:extLst>
-          </p:cNvPr>
-          <p:cNvSpPr>
-            <a:spLocks xmlns:a="http://schemas.openxmlformats.org/drawingml/2006/main" noGrp="1"/>
-          </p:cNvSpPr>
-          <p:nvPr/>
-        </p:nvSpPr>
-        <p:spPr>
-          <a:xfrm xmlns:a="http://schemas.openxmlformats.org/drawingml/2006/main">
-            <a:off x="7962900" y="1657350"/>
-            <a:ext cx="3505200" cy="1581150"/>
-          </a:xfrm>
-          <a:prstGeom xmlns:a="http://schemas.openxmlformats.org/drawingml/2006/main" prst="rect">
-            <a:avLst/>
-          </a:prstGeom>
-          <a:solidFill xmlns:a="http://schemas.openxmlformats.org/drawingml/2006/main">
-            <a:srgbClr val="102F49"/>
-          </a:solidFill>
-          <a:ln xmlns:a="http://schemas.openxmlformats.org/drawingml/2006/main" w="0">
-            <a:noFill/>
-          </a:ln>
-        </p:spPr>
-      </p:sp>
-      <p:sp>
-        <p:nvSpPr>
-          <p:cNvPr id="10" name="">
-            <a:extLst xmlns:a="http://schemas.openxmlformats.org/drawingml/2006/main">
-              <a:ext uri="{FF2B5EF4-FFF2-40B4-BE49-F238E27FC236}">
-                <a16:creationId xmlns:a16="http://schemas.microsoft.com/office/drawing/2014/main" id="{8425B898-C7C8-4B7D-B9D5-6AC741F7EE22}"/>
-              </a:ext>
-            </a:extLst>
-          </p:cNvPr>
-          <p:cNvSpPr>
-            <a:spLocks xmlns:a="http://schemas.openxmlformats.org/drawingml/2006/main" noGrp="1"/>
-          </p:cNvSpPr>
-          <p:nvPr/>
-        </p:nvSpPr>
-        <p:spPr>
-          <a:xfrm xmlns:a="http://schemas.openxmlformats.org/drawingml/2006/main">
-            <a:off x="8267700" y="1790700"/>
-            <a:ext cx="2895600" cy="762000"/>
-          </a:xfrm>
-          <a:prstGeom xmlns:a="http://schemas.openxmlformats.org/drawingml/2006/main" prst="rect">
-            <a:avLst/>
-          </a:prstGeom>
-          <a:noFill xmlns:a="http://schemas.openxmlformats.org/drawingml/2006/main"/>
-          <a:ln xmlns:a="http://schemas.openxmlformats.org/drawingml/2006/main" w="0">
-            <a:noFill/>
-          </a:ln>
-        </p:spPr>
-        <p:txBody>
-          <a:bodyPr xmlns:a="http://schemas.openxmlformats.org/drawingml/2006/main" anchor="ctr">
-            <a:noAutofit/>
-          </a:bodyPr>
-          <a:lstStyle xmlns:a="http://schemas.openxmlformats.org/drawingml/2006/main"/>
-          <a:p xmlns:a="http://schemas.openxmlformats.org/drawingml/2006/main">
-            <a:pPr algn="ctr">
-              <a:defRPr sz="4650" b="1" i="0">
-                <a:solidFill>
-                  <a:srgbClr val="F4B52A"/>
-                </a:solidFill>
-                <a:latin typeface="Arial"/>
-                <a:ea typeface="Arial"/>
-                <a:cs typeface="Arial"/>
-              </a:defRPr>
-            </a:pPr>
-            <a:r>
-              <a:rPr sz="4650" b="1" i="0">
-                <a:solidFill>
-                  <a:srgbClr val="F4B52A"/>
-                </a:solidFill>
-                <a:latin typeface="Arial"/>
-                <a:ea typeface="Arial"/>
-                <a:cs typeface="Arial"/>
-              </a:rPr>
-              <a:t>36%</a:t>
-            </a:r>
-          </a:p>
-        </p:txBody>
-      </p:sp>
-      <p:sp>
-        <p:nvSpPr>
-          <p:cNvPr id="11" name="">
-            <a:extLst xmlns:a="http://schemas.openxmlformats.org/drawingml/2006/main">
-              <a:ext uri="{FF2B5EF4-FFF2-40B4-BE49-F238E27FC236}">
-                <a16:creationId xmlns:a16="http://schemas.microsoft.com/office/drawing/2014/main" id="{094A58A1-4CBA-4ECB-A04A-FE9D633A1356}"/>
-              </a:ext>
-            </a:extLst>
-          </p:cNvPr>
-          <p:cNvSpPr>
-            <a:spLocks xmlns:a="http://schemas.openxmlformats.org/drawingml/2006/main" noGrp="1"/>
-          </p:cNvSpPr>
-          <p:nvPr/>
-        </p:nvSpPr>
-        <p:spPr>
-          <a:xfrm xmlns:a="http://schemas.openxmlformats.org/drawingml/2006/main">
-            <a:off x="8267700" y="2571750"/>
-            <a:ext cx="2895600" cy="400050"/>
-          </a:xfrm>
-          <a:prstGeom xmlns:a="http://schemas.openxmlformats.org/drawingml/2006/main" prst="rect">
-            <a:avLst/>
-          </a:prstGeom>
-          <a:noFill xmlns:a="http://schemas.openxmlformats.org/drawingml/2006/main"/>
-          <a:ln xmlns:a="http://schemas.openxmlformats.org/drawingml/2006/main" w="0">
-            <a:noFill/>
-          </a:ln>
-        </p:spPr>
-        <p:txBody>
-          <a:bodyPr xmlns:a="http://schemas.openxmlformats.org/drawingml/2006/main" anchor="ctr">
-            <a:noAutofit/>
-          </a:bodyPr>
-          <a:lstStyle xmlns:a="http://schemas.openxmlformats.org/drawingml/2006/main"/>
-          <a:p xmlns:a="http://schemas.openxmlformats.org/drawingml/2006/main">
-            <a:pPr algn="ctr">
-              <a:defRPr sz="1275" b="1" i="0">
-                <a:solidFill>
-                  <a:srgbClr val="FFFFFF"/>
-                </a:solidFill>
-                <a:latin typeface="Arial"/>
-                <a:ea typeface="Arial"/>
-                <a:cs typeface="Arial"/>
-              </a:defRPr>
-            </a:pPr>
-            <a:r>
-              <a:rPr sz="1275" b="1" i="0">
-                <a:solidFill>
-                  <a:srgbClr val="FFFFFF"/>
-                </a:solidFill>
-                <a:latin typeface="Arial"/>
-                <a:ea typeface="Arial"/>
-                <a:cs typeface="Arial"/>
-              </a:rPr>
-              <a:t>average current-module progress</a:t>
-            </a:r>
-          </a:p>
-        </p:txBody>
-      </p:sp>
-      <p:sp>
-        <p:nvSpPr>
-          <p:cNvPr id="12" name="">
-            <a:extLst xmlns:a="http://schemas.openxmlformats.org/drawingml/2006/main">
-              <a:ext uri="{FF2B5EF4-FFF2-40B4-BE49-F238E27FC236}">
-                <a16:creationId xmlns:a16="http://schemas.microsoft.com/office/drawing/2014/main" id="{48092BC2-C5D9-443D-B17C-FC19E949D12B}"/>
-              </a:ext>
-            </a:extLst>
-          </p:cNvPr>
-          <p:cNvSpPr>
-            <a:spLocks xmlns:a="http://schemas.openxmlformats.org/drawingml/2006/main" noGrp="1"/>
-          </p:cNvSpPr>
-          <p:nvPr/>
-        </p:nvSpPr>
-        <p:spPr>
-          <a:xfrm xmlns:a="http://schemas.openxmlformats.org/drawingml/2006/main">
-            <a:off x="7962900" y="3524250"/>
-            <a:ext cx="3505200" cy="2000250"/>
-          </a:xfrm>
-          <a:prstGeom xmlns:a="http://schemas.openxmlformats.org/drawingml/2006/main" prst="rect">
-            <a:avLst/>
-          </a:prstGeom>
-          <a:solidFill xmlns:a="http://schemas.openxmlformats.org/drawingml/2006/main">
-            <a:srgbClr val="E4F4EF"/>
-          </a:solidFill>
-          <a:ln xmlns:a="http://schemas.openxmlformats.org/drawingml/2006/main" w="0">
-            <a:noFill/>
-          </a:ln>
-        </p:spPr>
-      </p:sp>
-      <p:sp>
-        <p:nvSpPr>
-          <p:cNvPr id="13" name="">
-            <a:extLst xmlns:a="http://schemas.openxmlformats.org/drawingml/2006/main">
-              <a:ext uri="{FF2B5EF4-FFF2-40B4-BE49-F238E27FC236}">
-                <a16:creationId xmlns:a16="http://schemas.microsoft.com/office/drawing/2014/main" id="{C5FFB3AA-6816-462C-B26B-C22A6087915A}"/>
-              </a:ext>
-            </a:extLst>
-          </p:cNvPr>
-          <p:cNvSpPr>
-            <a:spLocks xmlns:a="http://schemas.openxmlformats.org/drawingml/2006/main" noGrp="1"/>
-          </p:cNvSpPr>
-          <p:nvPr/>
-        </p:nvSpPr>
-        <p:spPr>
-          <a:xfrm xmlns:a="http://schemas.openxmlformats.org/drawingml/2006/main">
-            <a:off x="8248650" y="3695700"/>
-            <a:ext cx="2933700" cy="323850"/>
-          </a:xfrm>
-          <a:prstGeom xmlns:a="http://schemas.openxmlformats.org/drawingml/2006/main" prst="rect">
-            <a:avLst/>
-          </a:prstGeom>
-          <a:noFill xmlns:a="http://schemas.openxmlformats.org/drawingml/2006/main"/>
-          <a:ln xmlns:a="http://schemas.openxmlformats.org/drawingml/2006/main" w="0">
-            <a:noFill/>
-          </a:ln>
-        </p:spPr>
-        <p:txBody>
-          <a:bodyPr xmlns:a="http://schemas.openxmlformats.org/drawingml/2006/main" anchor="ctr">
-            <a:noAutofit/>
-          </a:bodyPr>
-          <a:lstStyle xmlns:a="http://schemas.openxmlformats.org/drawingml/2006/main"/>
-          <a:p xmlns:a="http://schemas.openxmlformats.org/drawingml/2006/main">
-            <a:pPr algn="l">
-              <a:defRPr sz="1650" b="1" i="0">
-                <a:solidFill>
-                  <a:srgbClr val="168A6B"/>
-                </a:solidFill>
-                <a:latin typeface="Arial"/>
-                <a:ea typeface="Arial"/>
-                <a:cs typeface="Arial"/>
-              </a:defRPr>
-            </a:pPr>
-            <a:r>
-              <a:rPr sz="1650" b="1" i="0">
-                <a:solidFill>
-                  <a:srgbClr val="168A6B"/>
-                </a:solidFill>
-                <a:latin typeface="Arial"/>
-                <a:ea typeface="Arial"/>
-                <a:cs typeface="Arial"/>
-              </a:rPr>
-              <a:t>Friday sequence</a:t>
-            </a:r>
-          </a:p>
-        </p:txBody>
-      </p:sp>
-      <p:sp>
-        <p:nvSpPr>
-          <p:cNvPr id="14" name="">
-            <a:extLst xmlns:a="http://schemas.openxmlformats.org/drawingml/2006/main">
-              <a:ext uri="{FF2B5EF4-FFF2-40B4-BE49-F238E27FC236}">
-                <a16:creationId xmlns:a16="http://schemas.microsoft.com/office/drawing/2014/main" id="{C71E1065-B9A1-438F-B76E-8F78526AD27F}"/>
-              </a:ext>
-            </a:extLst>
-          </p:cNvPr>
-          <p:cNvSpPr>
-            <a:spLocks xmlns:a="http://schemas.openxmlformats.org/drawingml/2006/main" noGrp="1"/>
-          </p:cNvSpPr>
-          <p:nvPr/>
-        </p:nvSpPr>
-        <p:spPr>
-          <a:xfrm xmlns:a="http://schemas.openxmlformats.org/drawingml/2006/main">
-            <a:off x="8248650" y="4076700"/>
-            <a:ext cx="2933700" cy="1219200"/>
-          </a:xfrm>
-          <a:prstGeom xmlns:a="http://schemas.openxmlformats.org/drawingml/2006/main" prst="rect">
-            <a:avLst/>
-          </a:prstGeom>
-          <a:noFill xmlns:a="http://schemas.openxmlformats.org/drawingml/2006/main"/>
-          <a:ln xmlns:a="http://schemas.openxmlformats.org/drawingml/2006/main" w="0">
-            <a:noFill/>
-          </a:ln>
-        </p:spPr>
-        <p:txBody>
-          <a:bodyPr xmlns:a="http://schemas.openxmlformats.org/drawingml/2006/main" anchor="t">
-            <a:noAutofit/>
-          </a:bodyPr>
-          <a:lstStyle xmlns:a="http://schemas.openxmlformats.org/drawingml/2006/main"/>
-          <a:p xmlns:a="http://schemas.openxmlformats.org/drawingml/2006/main">
-            <a:pPr algn="l">
-              <a:defRPr sz="1500" b="1" i="0">
-                <a:solidFill>
-                  <a:srgbClr val="193B55"/>
-                </a:solidFill>
-                <a:latin typeface="Arial"/>
-                <a:ea typeface="Arial"/>
-                <a:cs typeface="Arial"/>
-              </a:defRPr>
-            </a:pPr>
-            <a:r>
-              <a:rPr sz="1500" b="1" i="0">
-                <a:solidFill>
-                  <a:srgbClr val="193B55"/>
-                </a:solidFill>
-                <a:latin typeface="Arial"/>
-                <a:ea typeface="Arial"/>
-                <a:cs typeface="Arial"/>
-              </a:rPr>
-              <a:t>Coordinate changes</a:t>
-            </a:r>
-          </a:p>
-          <a:p xmlns:a="http://schemas.openxmlformats.org/drawingml/2006/main">
-            <a:pPr algn="l">
-              <a:defRPr sz="1500" b="1" i="0">
-                <a:solidFill>
-                  <a:srgbClr val="193B55"/>
-                </a:solidFill>
-                <a:latin typeface="Arial"/>
-                <a:ea typeface="Arial"/>
-                <a:cs typeface="Arial"/>
-              </a:defRPr>
-            </a:pPr>
-            <a:r>
-              <a:rPr sz="1500" b="1" i="0">
-                <a:solidFill>
-                  <a:srgbClr val="193B55"/>
-                </a:solidFill>
-                <a:latin typeface="Arial"/>
-                <a:ea typeface="Arial"/>
-                <a:cs typeface="Arial"/>
-              </a:rPr>
-              <a:t>Distance and midpoint</a:t>
-            </a:r>
-          </a:p>
-          <a:p xmlns:a="http://schemas.openxmlformats.org/drawingml/2006/main">
-            <a:pPr algn="l">
-              <a:defRPr sz="1500" b="1" i="0">
-                <a:solidFill>
-                  <a:srgbClr val="193B55"/>
-                </a:solidFill>
-                <a:latin typeface="Arial"/>
-                <a:ea typeface="Arial"/>
-                <a:cs typeface="Arial"/>
-              </a:defRPr>
-            </a:pPr>
-            <a:r>
-              <a:rPr sz="1500" b="1" i="0">
-                <a:solidFill>
-                  <a:srgbClr val="193B55"/>
-                </a:solidFill>
-                <a:latin typeface="Arial"/>
-                <a:ea typeface="Arial"/>
-                <a:cs typeface="Arial"/>
-              </a:rPr>
-              <a:t>Slope and line equations</a:t>
-            </a:r>
-          </a:p>
-          <a:p xmlns:a="http://schemas.openxmlformats.org/drawingml/2006/main">
-            <a:pPr algn="l">
-              <a:defRPr sz="1500" b="1" i="0">
-                <a:solidFill>
-                  <a:srgbClr val="193B55"/>
-                </a:solidFill>
-                <a:latin typeface="Arial"/>
-                <a:ea typeface="Arial"/>
-                <a:cs typeface="Arial"/>
-              </a:defRPr>
-            </a:pPr>
-            <a:r>
-              <a:rPr sz="1500" b="1" i="0">
-                <a:solidFill>
-                  <a:srgbClr val="193B55"/>
-                </a:solidFill>
-                <a:latin typeface="Arial"/>
-                <a:ea typeface="Arial"/>
-                <a:cs typeface="Arial"/>
-              </a:rPr>
-              <a:t>Circle form</a:t>
-            </a:r>
-          </a:p>
-        </p:txBody>
-      </p:sp>
     </p:spTree>
     <p:extLst>
       <p:ext uri="{BB962C8B-B14F-4D97-AF65-F5344CB8AC3E}">
@@ -12862,6 +13034,7 @@
           <a:lstStyle xmlns:a="http://schemas.openxmlformats.org/drawingml/2006/main"/>
           <a:p xmlns:a="http://schemas.openxmlformats.org/drawingml/2006/main">
             <a:pPr algn="l">
+              <a:buNone/>
               <a:defRPr sz="2250" b="1" i="0">
                 <a:solidFill>
                   <a:srgbClr val="193B55"/>
@@ -12919,6 +13092,7 @@
           <a:lstStyle xmlns:a="http://schemas.openxmlformats.org/drawingml/2006/main"/>
           <a:p xmlns:a="http://schemas.openxmlformats.org/drawingml/2006/main">
             <a:pPr algn="l">
+              <a:buNone/>
               <a:defRPr sz="1125" b="0" i="0">
                 <a:solidFill>
                   <a:srgbClr val="60798D"/>
@@ -12976,6 +13150,7 @@
           <a:lstStyle xmlns:a="http://schemas.openxmlformats.org/drawingml/2006/main"/>
           <a:p xmlns:a="http://schemas.openxmlformats.org/drawingml/2006/main">
             <a:pPr algn="r">
+              <a:buNone/>
               <a:defRPr sz="900" b="1" i="0">
                 <a:solidFill>
                   <a:srgbClr val="F4B52A"/>
@@ -13063,6 +13238,7 @@
           <a:lstStyle xmlns:a="http://schemas.openxmlformats.org/drawingml/2006/main"/>
           <a:p xmlns:a="http://schemas.openxmlformats.org/drawingml/2006/main">
             <a:pPr algn="l">
+              <a:buNone/>
               <a:defRPr sz="675" b="1" i="0">
                 <a:solidFill>
                   <a:srgbClr val="60798D"/>
@@ -13120,6 +13296,7 @@
           <a:lstStyle xmlns:a="http://schemas.openxmlformats.org/drawingml/2006/main"/>
           <a:p xmlns:a="http://schemas.openxmlformats.org/drawingml/2006/main">
             <a:pPr algn="r">
+              <a:buNone/>
               <a:defRPr sz="675" b="0" i="0">
                 <a:solidFill>
                   <a:srgbClr val="60798D"/>
@@ -13207,6 +13384,7 @@
           <a:lstStyle xmlns:a="http://schemas.openxmlformats.org/drawingml/2006/main"/>
           <a:p xmlns:a="http://schemas.openxmlformats.org/drawingml/2006/main">
             <a:pPr algn="ctr">
+              <a:buNone/>
               <a:defRPr sz="1500" b="1" i="0">
                 <a:solidFill>
                   <a:srgbClr val="FFFFFF"/>
@@ -13264,6 +13442,7 @@
           <a:lstStyle xmlns:a="http://schemas.openxmlformats.org/drawingml/2006/main"/>
           <a:p xmlns:a="http://schemas.openxmlformats.org/drawingml/2006/main">
             <a:pPr algn="l">
+              <a:buNone/>
               <a:defRPr sz="1800" b="1" i="0">
                 <a:solidFill>
                   <a:srgbClr val="193B55"/>
@@ -13351,6 +13530,7 @@
           <a:lstStyle xmlns:a="http://schemas.openxmlformats.org/drawingml/2006/main"/>
           <a:p xmlns:a="http://schemas.openxmlformats.org/drawingml/2006/main">
             <a:pPr algn="ctr">
+              <a:buNone/>
               <a:defRPr sz="1500" b="1" i="0">
                 <a:solidFill>
                   <a:srgbClr val="FFFFFF"/>
@@ -13408,6 +13588,7 @@
           <a:lstStyle xmlns:a="http://schemas.openxmlformats.org/drawingml/2006/main"/>
           <a:p xmlns:a="http://schemas.openxmlformats.org/drawingml/2006/main">
             <a:pPr algn="l">
+              <a:buNone/>
               <a:defRPr sz="1800" b="1" i="0">
                 <a:solidFill>
                   <a:srgbClr val="193B55"/>
@@ -13495,6 +13676,7 @@
           <a:lstStyle xmlns:a="http://schemas.openxmlformats.org/drawingml/2006/main"/>
           <a:p xmlns:a="http://schemas.openxmlformats.org/drawingml/2006/main">
             <a:pPr algn="ctr">
+              <a:buNone/>
               <a:defRPr sz="1500" b="1" i="0">
                 <a:solidFill>
                   <a:srgbClr val="FFFFFF"/>
@@ -13552,6 +13734,7 @@
           <a:lstStyle xmlns:a="http://schemas.openxmlformats.org/drawingml/2006/main"/>
           <a:p xmlns:a="http://schemas.openxmlformats.org/drawingml/2006/main">
             <a:pPr algn="l">
+              <a:buNone/>
               <a:defRPr sz="1800" b="1" i="0">
                 <a:solidFill>
                   <a:srgbClr val="193B55"/>
@@ -13639,6 +13822,7 @@
           <a:lstStyle xmlns:a="http://schemas.openxmlformats.org/drawingml/2006/main"/>
           <a:p xmlns:a="http://schemas.openxmlformats.org/drawingml/2006/main">
             <a:pPr algn="ctr">
+              <a:buNone/>
               <a:defRPr sz="1800" b="1" i="0">
                 <a:solidFill>
                   <a:srgbClr val="193B55"/>
@@ -13755,6 +13939,7 @@
           <a:lstStyle xmlns:a="http://schemas.openxmlformats.org/drawingml/2006/main"/>
           <a:p xmlns:a="http://schemas.openxmlformats.org/drawingml/2006/main">
             <a:pPr algn="l">
+              <a:buNone/>
               <a:defRPr sz="2250" b="1" i="0">
                 <a:solidFill>
                   <a:srgbClr val="193B55"/>
@@ -13812,6 +13997,7 @@
           <a:lstStyle xmlns:a="http://schemas.openxmlformats.org/drawingml/2006/main"/>
           <a:p xmlns:a="http://schemas.openxmlformats.org/drawingml/2006/main">
             <a:pPr algn="l">
+              <a:buNone/>
               <a:defRPr sz="1125" b="0" i="0">
                 <a:solidFill>
                   <a:srgbClr val="60798D"/>
@@ -13869,6 +14055,7 @@
           <a:lstStyle xmlns:a="http://schemas.openxmlformats.org/drawingml/2006/main"/>
           <a:p xmlns:a="http://schemas.openxmlformats.org/drawingml/2006/main">
             <a:pPr algn="r">
+              <a:buNone/>
               <a:defRPr sz="900" b="1" i="0">
                 <a:solidFill>
                   <a:srgbClr val="168A6B"/>
@@ -13956,6 +14143,7 @@
           <a:lstStyle xmlns:a="http://schemas.openxmlformats.org/drawingml/2006/main"/>
           <a:p xmlns:a="http://schemas.openxmlformats.org/drawingml/2006/main">
             <a:pPr algn="l">
+              <a:buNone/>
               <a:defRPr sz="675" b="1" i="0">
                 <a:solidFill>
                   <a:srgbClr val="60798D"/>
@@ -14013,6 +14201,7 @@
           <a:lstStyle xmlns:a="http://schemas.openxmlformats.org/drawingml/2006/main"/>
           <a:p xmlns:a="http://schemas.openxmlformats.org/drawingml/2006/main">
             <a:pPr algn="r">
+              <a:buNone/>
               <a:defRPr sz="675" b="0" i="0">
                 <a:solidFill>
                   <a:srgbClr val="60798D"/>
@@ -14100,6 +14289,7 @@
           <a:lstStyle xmlns:a="http://schemas.openxmlformats.org/drawingml/2006/main"/>
           <a:p xmlns:a="http://schemas.openxmlformats.org/drawingml/2006/main">
             <a:pPr algn="ctr">
+              <a:buNone/>
               <a:defRPr sz="1500" b="1" i="0">
                 <a:solidFill>
                   <a:srgbClr val="FFFFFF"/>
@@ -14157,6 +14347,7 @@
           <a:lstStyle xmlns:a="http://schemas.openxmlformats.org/drawingml/2006/main"/>
           <a:p xmlns:a="http://schemas.openxmlformats.org/drawingml/2006/main">
             <a:pPr algn="l">
+              <a:buNone/>
               <a:defRPr sz="1725" b="1" i="0">
                 <a:solidFill>
                   <a:srgbClr val="193B55"/>
@@ -14244,6 +14435,7 @@
           <a:lstStyle xmlns:a="http://schemas.openxmlformats.org/drawingml/2006/main"/>
           <a:p xmlns:a="http://schemas.openxmlformats.org/drawingml/2006/main">
             <a:pPr algn="ctr">
+              <a:buNone/>
               <a:defRPr sz="1500" b="1" i="0">
                 <a:solidFill>
                   <a:srgbClr val="FFFFFF"/>
@@ -14301,6 +14493,7 @@
           <a:lstStyle xmlns:a="http://schemas.openxmlformats.org/drawingml/2006/main"/>
           <a:p xmlns:a="http://schemas.openxmlformats.org/drawingml/2006/main">
             <a:pPr algn="l">
+              <a:buNone/>
               <a:defRPr sz="1725" b="1" i="0">
                 <a:solidFill>
                   <a:srgbClr val="193B55"/>
@@ -14388,6 +14581,7 @@
           <a:lstStyle xmlns:a="http://schemas.openxmlformats.org/drawingml/2006/main"/>
           <a:p xmlns:a="http://schemas.openxmlformats.org/drawingml/2006/main">
             <a:pPr algn="ctr">
+              <a:buNone/>
               <a:defRPr sz="1500" b="1" i="0">
                 <a:solidFill>
                   <a:srgbClr val="FFFFFF"/>
@@ -14445,6 +14639,7 @@
           <a:lstStyle xmlns:a="http://schemas.openxmlformats.org/drawingml/2006/main"/>
           <a:p xmlns:a="http://schemas.openxmlformats.org/drawingml/2006/main">
             <a:pPr algn="l">
+              <a:buNone/>
               <a:defRPr sz="1725" b="1" i="0">
                 <a:solidFill>
                   <a:srgbClr val="193B55"/>
@@ -14532,6 +14727,7 @@
           <a:lstStyle xmlns:a="http://schemas.openxmlformats.org/drawingml/2006/main"/>
           <a:p xmlns:a="http://schemas.openxmlformats.org/drawingml/2006/main">
             <a:pPr algn="ctr">
+              <a:buNone/>
               <a:defRPr sz="1875" b="1" i="0">
                 <a:solidFill>
                   <a:srgbClr val="168A6B"/>
@@ -14648,6 +14844,7 @@
           <a:lstStyle xmlns:a="http://schemas.openxmlformats.org/drawingml/2006/main"/>
           <a:p xmlns:a="http://schemas.openxmlformats.org/drawingml/2006/main">
             <a:pPr algn="l">
+              <a:buNone/>
               <a:defRPr sz="2250" b="1" i="0">
                 <a:solidFill>
                   <a:srgbClr val="193B55"/>
@@ -14705,6 +14902,7 @@
           <a:lstStyle xmlns:a="http://schemas.openxmlformats.org/drawingml/2006/main"/>
           <a:p xmlns:a="http://schemas.openxmlformats.org/drawingml/2006/main">
             <a:pPr algn="l">
+              <a:buNone/>
               <a:defRPr sz="1125" b="0" i="0">
                 <a:solidFill>
                   <a:srgbClr val="60798D"/>
@@ -14762,6 +14960,7 @@
           <a:lstStyle xmlns:a="http://schemas.openxmlformats.org/drawingml/2006/main"/>
           <a:p xmlns:a="http://schemas.openxmlformats.org/drawingml/2006/main">
             <a:pPr algn="r">
+              <a:buNone/>
               <a:defRPr sz="900" b="1" i="0">
                 <a:solidFill>
                   <a:srgbClr val="1777B4"/>
@@ -14849,6 +15048,7 @@
           <a:lstStyle xmlns:a="http://schemas.openxmlformats.org/drawingml/2006/main"/>
           <a:p xmlns:a="http://schemas.openxmlformats.org/drawingml/2006/main">
             <a:pPr algn="l">
+              <a:buNone/>
               <a:defRPr sz="675" b="1" i="0">
                 <a:solidFill>
                   <a:srgbClr val="60798D"/>
@@ -14906,6 +15106,7 @@
           <a:lstStyle xmlns:a="http://schemas.openxmlformats.org/drawingml/2006/main"/>
           <a:p xmlns:a="http://schemas.openxmlformats.org/drawingml/2006/main">
             <a:pPr algn="r">
+              <a:buNone/>
               <a:defRPr sz="675" b="0" i="0">
                 <a:solidFill>
                   <a:srgbClr val="60798D"/>
@@ -15595,6 +15796,7 @@
           <a:lstStyle xmlns:a="http://schemas.openxmlformats.org/drawingml/2006/main"/>
           <a:p xmlns:a="http://schemas.openxmlformats.org/drawingml/2006/main">
             <a:pPr algn="ctr">
+              <a:buNone/>
               <a:defRPr sz="900" b="0" i="0">
                 <a:solidFill>
                   <a:srgbClr val="60798D"/>
@@ -15652,6 +15854,7 @@
           <a:lstStyle xmlns:a="http://schemas.openxmlformats.org/drawingml/2006/main"/>
           <a:p xmlns:a="http://schemas.openxmlformats.org/drawingml/2006/main">
             <a:pPr algn="ctr">
+              <a:buNone/>
               <a:defRPr sz="900" b="0" i="0">
                 <a:solidFill>
                   <a:srgbClr val="60798D"/>
@@ -15709,6 +15912,7 @@
           <a:lstStyle xmlns:a="http://schemas.openxmlformats.org/drawingml/2006/main"/>
           <a:p xmlns:a="http://schemas.openxmlformats.org/drawingml/2006/main">
             <a:pPr algn="ctr">
+              <a:buNone/>
               <a:defRPr sz="900" b="0" i="0">
                 <a:solidFill>
                   <a:srgbClr val="60798D"/>
@@ -15766,6 +15970,7 @@
           <a:lstStyle xmlns:a="http://schemas.openxmlformats.org/drawingml/2006/main"/>
           <a:p xmlns:a="http://schemas.openxmlformats.org/drawingml/2006/main">
             <a:pPr algn="ctr">
+              <a:buNone/>
               <a:defRPr sz="900" b="0" i="0">
                 <a:solidFill>
                   <a:srgbClr val="60798D"/>
@@ -15823,6 +16028,7 @@
           <a:lstStyle xmlns:a="http://schemas.openxmlformats.org/drawingml/2006/main"/>
           <a:p xmlns:a="http://schemas.openxmlformats.org/drawingml/2006/main">
             <a:pPr algn="ctr">
+              <a:buNone/>
               <a:defRPr sz="900" b="0" i="0">
                 <a:solidFill>
                   <a:srgbClr val="60798D"/>
@@ -15880,6 +16086,7 @@
           <a:lstStyle xmlns:a="http://schemas.openxmlformats.org/drawingml/2006/main"/>
           <a:p xmlns:a="http://schemas.openxmlformats.org/drawingml/2006/main">
             <a:pPr algn="ctr">
+              <a:buNone/>
               <a:defRPr sz="900" b="0" i="0">
                 <a:solidFill>
                   <a:srgbClr val="60798D"/>
@@ -15937,6 +16144,7 @@
           <a:lstStyle xmlns:a="http://schemas.openxmlformats.org/drawingml/2006/main"/>
           <a:p xmlns:a="http://schemas.openxmlformats.org/drawingml/2006/main">
             <a:pPr algn="ctr">
+              <a:buNone/>
               <a:defRPr sz="900" b="0" i="0">
                 <a:solidFill>
                   <a:srgbClr val="60798D"/>
@@ -15994,6 +16202,7 @@
           <a:lstStyle xmlns:a="http://schemas.openxmlformats.org/drawingml/2006/main"/>
           <a:p xmlns:a="http://schemas.openxmlformats.org/drawingml/2006/main">
             <a:pPr algn="ctr">
+              <a:buNone/>
               <a:defRPr sz="900" b="0" i="0">
                 <a:solidFill>
                   <a:srgbClr val="60798D"/>
@@ -16051,6 +16260,7 @@
           <a:lstStyle xmlns:a="http://schemas.openxmlformats.org/drawingml/2006/main"/>
           <a:p xmlns:a="http://schemas.openxmlformats.org/drawingml/2006/main">
             <a:pPr algn="r">
+              <a:buNone/>
               <a:defRPr sz="900" b="0" i="0">
                 <a:solidFill>
                   <a:srgbClr val="60798D"/>
@@ -16108,6 +16318,7 @@
           <a:lstStyle xmlns:a="http://schemas.openxmlformats.org/drawingml/2006/main"/>
           <a:p xmlns:a="http://schemas.openxmlformats.org/drawingml/2006/main">
             <a:pPr algn="r">
+              <a:buNone/>
               <a:defRPr sz="900" b="0" i="0">
                 <a:solidFill>
                   <a:srgbClr val="60798D"/>
@@ -16165,6 +16376,7 @@
           <a:lstStyle xmlns:a="http://schemas.openxmlformats.org/drawingml/2006/main"/>
           <a:p xmlns:a="http://schemas.openxmlformats.org/drawingml/2006/main">
             <a:pPr algn="r">
+              <a:buNone/>
               <a:defRPr sz="900" b="0" i="0">
                 <a:solidFill>
                   <a:srgbClr val="60798D"/>
@@ -16222,6 +16434,7 @@
           <a:lstStyle xmlns:a="http://schemas.openxmlformats.org/drawingml/2006/main"/>
           <a:p xmlns:a="http://schemas.openxmlformats.org/drawingml/2006/main">
             <a:pPr algn="r">
+              <a:buNone/>
               <a:defRPr sz="900" b="0" i="0">
                 <a:solidFill>
                   <a:srgbClr val="60798D"/>
@@ -16279,6 +16492,7 @@
           <a:lstStyle xmlns:a="http://schemas.openxmlformats.org/drawingml/2006/main"/>
           <a:p xmlns:a="http://schemas.openxmlformats.org/drawingml/2006/main">
             <a:pPr algn="r">
+              <a:buNone/>
               <a:defRPr sz="900" b="0" i="0">
                 <a:solidFill>
                   <a:srgbClr val="60798D"/>
@@ -16336,6 +16550,7 @@
           <a:lstStyle xmlns:a="http://schemas.openxmlformats.org/drawingml/2006/main"/>
           <a:p xmlns:a="http://schemas.openxmlformats.org/drawingml/2006/main">
             <a:pPr algn="r">
+              <a:buNone/>
               <a:defRPr sz="900" b="0" i="0">
                 <a:solidFill>
                   <a:srgbClr val="60798D"/>
@@ -16393,6 +16608,7 @@
           <a:lstStyle xmlns:a="http://schemas.openxmlformats.org/drawingml/2006/main"/>
           <a:p xmlns:a="http://schemas.openxmlformats.org/drawingml/2006/main">
             <a:pPr algn="r">
+              <a:buNone/>
               <a:defRPr sz="900" b="0" i="0">
                 <a:solidFill>
                   <a:srgbClr val="60798D"/>
@@ -16450,6 +16666,7 @@
           <a:lstStyle xmlns:a="http://schemas.openxmlformats.org/drawingml/2006/main"/>
           <a:p xmlns:a="http://schemas.openxmlformats.org/drawingml/2006/main">
             <a:pPr algn="l">
+              <a:buNone/>
               <a:defRPr sz="1275" b="1" i="0">
                 <a:solidFill>
                   <a:srgbClr val="193B55"/>
@@ -16507,6 +16724,7 @@
           <a:lstStyle xmlns:a="http://schemas.openxmlformats.org/drawingml/2006/main"/>
           <a:p xmlns:a="http://schemas.openxmlformats.org/drawingml/2006/main">
             <a:pPr algn="l">
+              <a:buNone/>
               <a:defRPr sz="1275" b="1" i="0">
                 <a:solidFill>
                   <a:srgbClr val="193B55"/>
@@ -16684,6 +16902,7 @@
           <a:lstStyle xmlns:a="http://schemas.openxmlformats.org/drawingml/2006/main"/>
           <a:p xmlns:a="http://schemas.openxmlformats.org/drawingml/2006/main">
             <a:pPr algn="l">
+              <a:buNone/>
               <a:defRPr sz="1125" b="1" i="0">
                 <a:solidFill>
                   <a:srgbClr val="E45D50"/>
@@ -16741,6 +16960,7 @@
           <a:lstStyle xmlns:a="http://schemas.openxmlformats.org/drawingml/2006/main"/>
           <a:p xmlns:a="http://schemas.openxmlformats.org/drawingml/2006/main">
             <a:pPr algn="l">
+              <a:buNone/>
               <a:defRPr sz="1125" b="1" i="0">
                 <a:solidFill>
                   <a:srgbClr val="E45D50"/>
@@ -16798,6 +17018,7 @@
           <a:lstStyle xmlns:a="http://schemas.openxmlformats.org/drawingml/2006/main"/>
           <a:p xmlns:a="http://schemas.openxmlformats.org/drawingml/2006/main">
             <a:pPr algn="ctr">
+              <a:buNone/>
               <a:defRPr sz="1200" b="1" i="0">
                 <a:solidFill>
                   <a:srgbClr val="1777B4"/>
@@ -16855,6 +17076,7 @@
           <a:lstStyle xmlns:a="http://schemas.openxmlformats.org/drawingml/2006/main"/>
           <a:p xmlns:a="http://schemas.openxmlformats.org/drawingml/2006/main">
             <a:pPr algn="l">
+              <a:buNone/>
               <a:defRPr sz="1200" b="1" i="0">
                 <a:solidFill>
                   <a:srgbClr val="168A6B"/>
@@ -16912,6 +17134,7 @@
           <a:lstStyle xmlns:a="http://schemas.openxmlformats.org/drawingml/2006/main"/>
           <a:p xmlns:a="http://schemas.openxmlformats.org/drawingml/2006/main">
             <a:pPr algn="l">
+              <a:buNone/>
               <a:defRPr sz="1425" b="1" i="0">
                 <a:solidFill>
                   <a:srgbClr val="1777B4"/>
@@ -16969,6 +17192,7 @@
           <a:lstStyle xmlns:a="http://schemas.openxmlformats.org/drawingml/2006/main"/>
           <a:p xmlns:a="http://schemas.openxmlformats.org/drawingml/2006/main">
             <a:pPr algn="l">
+              <a:buNone/>
               <a:defRPr sz="2025" b="1" i="0">
                 <a:solidFill>
                   <a:srgbClr val="193B55"/>
@@ -17026,6 +17250,7 @@
           <a:lstStyle xmlns:a="http://schemas.openxmlformats.org/drawingml/2006/main"/>
           <a:p xmlns:a="http://schemas.openxmlformats.org/drawingml/2006/main">
             <a:pPr algn="l">
+              <a:buNone/>
               <a:defRPr sz="1425" b="1" i="0">
                 <a:solidFill>
                   <a:srgbClr val="168A6B"/>
@@ -17083,6 +17308,7 @@
           <a:lstStyle xmlns:a="http://schemas.openxmlformats.org/drawingml/2006/main"/>
           <a:p xmlns:a="http://schemas.openxmlformats.org/drawingml/2006/main">
             <a:pPr algn="l">
+              <a:buNone/>
               <a:defRPr sz="2025" b="1" i="0">
                 <a:solidFill>
                   <a:srgbClr val="193B55"/>
@@ -17170,6 +17396,7 @@
           <a:lstStyle xmlns:a="http://schemas.openxmlformats.org/drawingml/2006/main"/>
           <a:p xmlns:a="http://schemas.openxmlformats.org/drawingml/2006/main">
             <a:pPr algn="ctr">
+              <a:buNone/>
               <a:defRPr sz="1650" b="1" i="0">
                 <a:solidFill>
                   <a:srgbClr val="193B55"/>
@@ -17286,6 +17513,7 @@
           <a:lstStyle xmlns:a="http://schemas.openxmlformats.org/drawingml/2006/main"/>
           <a:p xmlns:a="http://schemas.openxmlformats.org/drawingml/2006/main">
             <a:pPr algn="l">
+              <a:buNone/>
               <a:defRPr sz="2250" b="1" i="0">
                 <a:solidFill>
                   <a:srgbClr val="193B55"/>
@@ -17343,6 +17571,7 @@
           <a:lstStyle xmlns:a="http://schemas.openxmlformats.org/drawingml/2006/main"/>
           <a:p xmlns:a="http://schemas.openxmlformats.org/drawingml/2006/main">
             <a:pPr algn="l">
+              <a:buNone/>
               <a:defRPr sz="1125" b="0" i="0">
                 <a:solidFill>
                   <a:srgbClr val="60798D"/>
@@ -17400,6 +17629,7 @@
           <a:lstStyle xmlns:a="http://schemas.openxmlformats.org/drawingml/2006/main"/>
           <a:p xmlns:a="http://schemas.openxmlformats.org/drawingml/2006/main">
             <a:pPr algn="r">
+              <a:buNone/>
               <a:defRPr sz="900" b="1" i="0">
                 <a:solidFill>
                   <a:srgbClr val="1777B4"/>
@@ -17487,6 +17717,7 @@
           <a:lstStyle xmlns:a="http://schemas.openxmlformats.org/drawingml/2006/main"/>
           <a:p xmlns:a="http://schemas.openxmlformats.org/drawingml/2006/main">
             <a:pPr algn="l">
+              <a:buNone/>
               <a:defRPr sz="675" b="1" i="0">
                 <a:solidFill>
                   <a:srgbClr val="60798D"/>
@@ -17544,6 +17775,7 @@
           <a:lstStyle xmlns:a="http://schemas.openxmlformats.org/drawingml/2006/main"/>
           <a:p xmlns:a="http://schemas.openxmlformats.org/drawingml/2006/main">
             <a:pPr algn="r">
+              <a:buNone/>
               <a:defRPr sz="675" b="0" i="0">
                 <a:solidFill>
                   <a:srgbClr val="60798D"/>
@@ -17631,6 +17863,7 @@
           <a:lstStyle xmlns:a="http://schemas.openxmlformats.org/drawingml/2006/main"/>
           <a:p xmlns:a="http://schemas.openxmlformats.org/drawingml/2006/main">
             <a:pPr algn="l">
+              <a:buNone/>
               <a:defRPr sz="975" b="1" i="0">
                 <a:solidFill>
                   <a:srgbClr val="1777B4"/>
@@ -17688,6 +17921,7 @@
           <a:lstStyle xmlns:a="http://schemas.openxmlformats.org/drawingml/2006/main"/>
           <a:p xmlns:a="http://schemas.openxmlformats.org/drawingml/2006/main">
             <a:pPr algn="ctr">
+              <a:buNone/>
               <a:defRPr sz="2475" b="1" i="0">
                 <a:solidFill>
                   <a:srgbClr val="193B55"/>
@@ -17745,6 +17979,7 @@
           <a:lstStyle xmlns:a="http://schemas.openxmlformats.org/drawingml/2006/main"/>
           <a:p xmlns:a="http://schemas.openxmlformats.org/drawingml/2006/main">
             <a:pPr algn="ctr">
+              <a:buNone/>
               <a:defRPr sz="1350" b="0" i="0">
                 <a:solidFill>
                   <a:srgbClr val="60798D"/>
@@ -17832,6 +18067,7 @@
           <a:lstStyle xmlns:a="http://schemas.openxmlformats.org/drawingml/2006/main"/>
           <a:p xmlns:a="http://schemas.openxmlformats.org/drawingml/2006/main">
             <a:pPr algn="l">
+              <a:buNone/>
               <a:defRPr sz="975" b="1" i="0">
                 <a:solidFill>
                   <a:srgbClr val="168A6B"/>
@@ -17889,6 +18125,7 @@
           <a:lstStyle xmlns:a="http://schemas.openxmlformats.org/drawingml/2006/main"/>
           <a:p xmlns:a="http://schemas.openxmlformats.org/drawingml/2006/main">
             <a:pPr algn="ctr">
+              <a:buNone/>
               <a:defRPr sz="2400" b="1" i="0">
                 <a:solidFill>
                   <a:srgbClr val="193B55"/>
@@ -17946,6 +18183,7 @@
           <a:lstStyle xmlns:a="http://schemas.openxmlformats.org/drawingml/2006/main"/>
           <a:p xmlns:a="http://schemas.openxmlformats.org/drawingml/2006/main">
             <a:pPr algn="ctr">
+              <a:buNone/>
               <a:defRPr sz="1350" b="0" i="0">
                 <a:solidFill>
                   <a:srgbClr val="60798D"/>
@@ -18033,6 +18271,7 @@
           <a:lstStyle xmlns:a="http://schemas.openxmlformats.org/drawingml/2006/main"/>
           <a:p xmlns:a="http://schemas.openxmlformats.org/drawingml/2006/main">
             <a:pPr algn="ctr">
+              <a:buNone/>
               <a:defRPr sz="1800" b="1" i="0">
                 <a:solidFill>
                   <a:srgbClr val="193B55"/>
@@ -18149,6 +18388,7 @@
           <a:lstStyle xmlns:a="http://schemas.openxmlformats.org/drawingml/2006/main"/>
           <a:p xmlns:a="http://schemas.openxmlformats.org/drawingml/2006/main">
             <a:pPr algn="l">
+              <a:buNone/>
               <a:defRPr sz="2250" b="1" i="0">
                 <a:solidFill>
                   <a:srgbClr val="193B55"/>
@@ -18206,6 +18446,7 @@
           <a:lstStyle xmlns:a="http://schemas.openxmlformats.org/drawingml/2006/main"/>
           <a:p xmlns:a="http://schemas.openxmlformats.org/drawingml/2006/main">
             <a:pPr algn="l">
+              <a:buNone/>
               <a:defRPr sz="1125" b="0" i="0">
                 <a:solidFill>
                   <a:srgbClr val="60798D"/>
@@ -18263,6 +18504,7 @@
           <a:lstStyle xmlns:a="http://schemas.openxmlformats.org/drawingml/2006/main"/>
           <a:p xmlns:a="http://schemas.openxmlformats.org/drawingml/2006/main">
             <a:pPr algn="r">
+              <a:buNone/>
               <a:defRPr sz="900" b="1" i="0">
                 <a:solidFill>
                   <a:srgbClr val="1777B4"/>
@@ -18350,6 +18592,7 @@
           <a:lstStyle xmlns:a="http://schemas.openxmlformats.org/drawingml/2006/main"/>
           <a:p xmlns:a="http://schemas.openxmlformats.org/drawingml/2006/main">
             <a:pPr algn="l">
+              <a:buNone/>
               <a:defRPr sz="675" b="1" i="0">
                 <a:solidFill>
                   <a:srgbClr val="60798D"/>
@@ -18407,6 +18650,7 @@
           <a:lstStyle xmlns:a="http://schemas.openxmlformats.org/drawingml/2006/main"/>
           <a:p xmlns:a="http://schemas.openxmlformats.org/drawingml/2006/main">
             <a:pPr algn="r">
+              <a:buNone/>
               <a:defRPr sz="675" b="0" i="0">
                 <a:solidFill>
                   <a:srgbClr val="60798D"/>
@@ -18494,6 +18738,7 @@
           <a:lstStyle xmlns:a="http://schemas.openxmlformats.org/drawingml/2006/main"/>
           <a:p xmlns:a="http://schemas.openxmlformats.org/drawingml/2006/main">
             <a:pPr algn="ctr">
+              <a:buNone/>
               <a:defRPr sz="2325" b="1" i="0">
                 <a:solidFill>
                   <a:srgbClr val="193B55"/>
@@ -18581,6 +18826,7 @@
           <a:lstStyle xmlns:a="http://schemas.openxmlformats.org/drawingml/2006/main"/>
           <a:p xmlns:a="http://schemas.openxmlformats.org/drawingml/2006/main">
             <a:pPr algn="l">
+              <a:buNone/>
               <a:defRPr sz="1575" b="1" i="0">
                 <a:solidFill>
                   <a:srgbClr val="1777B4"/>
@@ -18638,6 +18884,7 @@
           <a:lstStyle xmlns:a="http://schemas.openxmlformats.org/drawingml/2006/main"/>
           <a:p xmlns:a="http://schemas.openxmlformats.org/drawingml/2006/main">
             <a:pPr algn="ctr">
+              <a:buNone/>
               <a:defRPr sz="2250" b="1" i="0">
                 <a:solidFill>
                   <a:srgbClr val="193B55"/>
@@ -18661,6 +18908,7 @@
           </a:p>
           <a:p xmlns:a="http://schemas.openxmlformats.org/drawingml/2006/main">
             <a:pPr algn="ctr">
+              <a:buNone/>
               <a:defRPr sz="2250" b="1" i="0">
                 <a:solidFill>
                   <a:srgbClr val="193B55"/>
@@ -18684,6 +18932,7 @@
           </a:p>
           <a:p xmlns:a="http://schemas.openxmlformats.org/drawingml/2006/main">
             <a:pPr algn="ctr">
+              <a:buNone/>
               <a:defRPr sz="2250" b="1" i="0">
                 <a:solidFill>
                   <a:srgbClr val="193B55"/>
@@ -18771,6 +19020,7 @@
           <a:lstStyle xmlns:a="http://schemas.openxmlformats.org/drawingml/2006/main"/>
           <a:p xmlns:a="http://schemas.openxmlformats.org/drawingml/2006/main">
             <a:pPr algn="l">
+              <a:buNone/>
               <a:defRPr sz="1575" b="1" i="0">
                 <a:solidFill>
                   <a:srgbClr val="168A6B"/>
@@ -18828,6 +19078,7 @@
           <a:lstStyle xmlns:a="http://schemas.openxmlformats.org/drawingml/2006/main"/>
           <a:p xmlns:a="http://schemas.openxmlformats.org/drawingml/2006/main">
             <a:pPr algn="ctr">
+              <a:buNone/>
               <a:defRPr sz="2100" b="1" i="0">
                 <a:solidFill>
                   <a:srgbClr val="193B55"/>
@@ -18851,6 +19102,7 @@
           </a:p>
           <a:p xmlns:a="http://schemas.openxmlformats.org/drawingml/2006/main">
             <a:pPr algn="ctr">
+              <a:buNone/>
               <a:defRPr sz="2100" b="1" i="0">
                 <a:solidFill>
                   <a:srgbClr val="193B55"/>
@@ -18874,6 +19126,7 @@
           </a:p>
           <a:p xmlns:a="http://schemas.openxmlformats.org/drawingml/2006/main">
             <a:pPr algn="ctr">
+              <a:buNone/>
               <a:defRPr sz="2100" b="1" i="0">
                 <a:solidFill>
                   <a:srgbClr val="193B55"/>
@@ -18931,6 +19184,7 @@
           <a:lstStyle xmlns:a="http://schemas.openxmlformats.org/drawingml/2006/main"/>
           <a:p xmlns:a="http://schemas.openxmlformats.org/drawingml/2006/main">
             <a:pPr algn="ctr">
+              <a:buNone/>
               <a:defRPr sz="1425" b="1" i="0">
                 <a:solidFill>
                   <a:srgbClr val="E45D50"/>
@@ -19047,6 +19301,7 @@
           <a:lstStyle xmlns:a="http://schemas.openxmlformats.org/drawingml/2006/main"/>
           <a:p xmlns:a="http://schemas.openxmlformats.org/drawingml/2006/main">
             <a:pPr algn="l">
+              <a:buNone/>
               <a:defRPr sz="2250" b="1" i="0">
                 <a:solidFill>
                   <a:srgbClr val="193B55"/>
@@ -19104,6 +19359,7 @@
           <a:lstStyle xmlns:a="http://schemas.openxmlformats.org/drawingml/2006/main"/>
           <a:p xmlns:a="http://schemas.openxmlformats.org/drawingml/2006/main">
             <a:pPr algn="l">
+              <a:buNone/>
               <a:defRPr sz="1125" b="0" i="0">
                 <a:solidFill>
                   <a:srgbClr val="60798D"/>
@@ -19161,6 +19417,7 @@
           <a:lstStyle xmlns:a="http://schemas.openxmlformats.org/drawingml/2006/main"/>
           <a:p xmlns:a="http://schemas.openxmlformats.org/drawingml/2006/main">
             <a:pPr algn="r">
+              <a:buNone/>
               <a:defRPr sz="900" b="1" i="0">
                 <a:solidFill>
                   <a:srgbClr val="F4B52A"/>
@@ -19248,6 +19505,7 @@
           <a:lstStyle xmlns:a="http://schemas.openxmlformats.org/drawingml/2006/main"/>
           <a:p xmlns:a="http://schemas.openxmlformats.org/drawingml/2006/main">
             <a:pPr algn="l">
+              <a:buNone/>
               <a:defRPr sz="675" b="1" i="0">
                 <a:solidFill>
                   <a:srgbClr val="60798D"/>
@@ -19305,6 +19563,7 @@
           <a:lstStyle xmlns:a="http://schemas.openxmlformats.org/drawingml/2006/main"/>
           <a:p xmlns:a="http://schemas.openxmlformats.org/drawingml/2006/main">
             <a:pPr algn="r">
+              <a:buNone/>
               <a:defRPr sz="675" b="0" i="0">
                 <a:solidFill>
                   <a:srgbClr val="60798D"/>
@@ -19392,6 +19651,7 @@
           <a:lstStyle xmlns:a="http://schemas.openxmlformats.org/drawingml/2006/main"/>
           <a:p xmlns:a="http://schemas.openxmlformats.org/drawingml/2006/main">
             <a:pPr algn="ctr">
+              <a:buNone/>
               <a:defRPr sz="3150" b="1" i="0">
                 <a:solidFill>
                   <a:srgbClr val="193B55"/>
@@ -19479,6 +19739,7 @@
           <a:lstStyle xmlns:a="http://schemas.openxmlformats.org/drawingml/2006/main"/>
           <a:p xmlns:a="http://schemas.openxmlformats.org/drawingml/2006/main">
             <a:pPr algn="ctr">
+              <a:buNone/>
               <a:defRPr sz="1500" b="1" i="0">
                 <a:solidFill>
                   <a:srgbClr val="FFFFFF"/>
@@ -19536,6 +19797,7 @@
           <a:lstStyle xmlns:a="http://schemas.openxmlformats.org/drawingml/2006/main"/>
           <a:p xmlns:a="http://schemas.openxmlformats.org/drawingml/2006/main">
             <a:pPr algn="l">
+              <a:buNone/>
               <a:defRPr sz="1875" b="1" i="0">
                 <a:solidFill>
                   <a:srgbClr val="193B55"/>
@@ -19623,6 +19885,7 @@
           <a:lstStyle xmlns:a="http://schemas.openxmlformats.org/drawingml/2006/main"/>
           <a:p xmlns:a="http://schemas.openxmlformats.org/drawingml/2006/main">
             <a:pPr algn="ctr">
+              <a:buNone/>
               <a:defRPr sz="1500" b="1" i="0">
                 <a:solidFill>
                   <a:srgbClr val="FFFFFF"/>
@@ -19680,6 +19943,7 @@
           <a:lstStyle xmlns:a="http://schemas.openxmlformats.org/drawingml/2006/main"/>
           <a:p xmlns:a="http://schemas.openxmlformats.org/drawingml/2006/main">
             <a:pPr algn="l">
+              <a:buNone/>
               <a:defRPr sz="1875" b="1" i="0">
                 <a:solidFill>
                   <a:srgbClr val="193B55"/>
@@ -19767,6 +20031,7 @@
           <a:lstStyle xmlns:a="http://schemas.openxmlformats.org/drawingml/2006/main"/>
           <a:p xmlns:a="http://schemas.openxmlformats.org/drawingml/2006/main">
             <a:pPr algn="ctr">
+              <a:buNone/>
               <a:defRPr sz="1500" b="1" i="0">
                 <a:solidFill>
                   <a:srgbClr val="FFFFFF"/>
@@ -19824,6 +20089,7 @@
           <a:lstStyle xmlns:a="http://schemas.openxmlformats.org/drawingml/2006/main"/>
           <a:p xmlns:a="http://schemas.openxmlformats.org/drawingml/2006/main">
             <a:pPr algn="l">
+              <a:buNone/>
               <a:defRPr sz="1875" b="1" i="0">
                 <a:solidFill>
                   <a:srgbClr val="193B55"/>
@@ -19881,6 +20147,7 @@
           <a:lstStyle xmlns:a="http://schemas.openxmlformats.org/drawingml/2006/main"/>
           <a:p xmlns:a="http://schemas.openxmlformats.org/drawingml/2006/main">
             <a:pPr algn="ctr">
+              <a:buNone/>
               <a:defRPr sz="1350" b="1" i="0">
                 <a:solidFill>
                   <a:srgbClr val="193B55"/>

</xml_diff>